<commit_message>
docs(en): finalize english deliverable localizations
- Standardize Chinese section headers to English numbered lists.

- Refine structural idioms ('Red-line patrol' -> 'What to look for', 'Double-insurance' -> 'Backup plan').

- Translate 'Localization notes' from Chinese to English while preserving source tracing.

- Localize '素材/' paths to 'assets/'.

- Update stale deck page metadata in early lessons.
</commit_message>
<xml_diff>
--- a/en/03_Deliverables/PPTX/M0_EN_Deck_CFG-5_Lesson00_BeforeFirstLight_v1.pptx
+++ b/en/03_Deliverables/PPTX/M0_EN_Deck_CFG-5_Lesson00_BeforeFirstLight_v1.pptx
@@ -4,22 +4,25 @@
   <p:sldMasterIdLst>
     <p:sldMasterId id="2147483648" r:id="rId1"/>
   </p:sldMasterIdLst>
+  <p:notesMasterIdLst>
+    <p:notesMasterId r:id="rId15"/>
+  </p:notesMasterIdLst>
   <p:sldIdLst>
-    <p:sldId id="256" r:id="rId7"/>
-    <p:sldId id="257" r:id="rId9"/>
-    <p:sldId id="258" r:id="rId10"/>
-    <p:sldId id="259" r:id="rId11"/>
-    <p:sldId id="260" r:id="rId12"/>
-    <p:sldId id="261" r:id="rId13"/>
-    <p:sldId id="262" r:id="rId14"/>
-    <p:sldId id="263" r:id="rId15"/>
-    <p:sldId id="264" r:id="rId16"/>
-    <p:sldId id="265" r:id="rId17"/>
-    <p:sldId id="266" r:id="rId18"/>
-    <p:sldId id="267" r:id="rId19"/>
-    <p:sldId id="268" r:id="rId20"/>
+    <p:sldId id="256" r:id="rId2"/>
+    <p:sldId id="257" r:id="rId3"/>
+    <p:sldId id="258" r:id="rId4"/>
+    <p:sldId id="259" r:id="rId5"/>
+    <p:sldId id="260" r:id="rId6"/>
+    <p:sldId id="261" r:id="rId7"/>
+    <p:sldId id="262" r:id="rId8"/>
+    <p:sldId id="263" r:id="rId9"/>
+    <p:sldId id="264" r:id="rId10"/>
+    <p:sldId id="265" r:id="rId11"/>
+    <p:sldId id="266" r:id="rId12"/>
+    <p:sldId id="267" r:id="rId13"/>
+    <p:sldId id="268" r:id="rId14"/>
   </p:sldIdLst>
-  <p:sldSz cx="9144000" cy="5143500" type="screen4x3"/>
+  <p:sldSz cx="9144000" cy="5143500" type="screen16x9"/>
   <p:notesSz cx="6858000" cy="9144000"/>
   <p:defaultTextStyle>
     <a:defPPr>
@@ -116,11 +119,27 @@
       </a:defRPr>
     </a:lvl9pPr>
   </p:defaultTextStyle>
+  <p:extLst>
+    <p:ext uri="{EFAFB233-063F-42B5-8137-9DF3F51BA10A}">
+      <p15:sldGuideLst xmlns:p15="http://schemas.microsoft.com/office/powerpoint/2012/main">
+        <p15:guide id="1" orient="horz" pos="2160">
+          <p15:clr>
+            <a:srgbClr val="A4A3A4"/>
+          </p15:clr>
+        </p15:guide>
+        <p15:guide id="2" pos="2880">
+          <p15:clr>
+            <a:srgbClr val="A4A3A4"/>
+          </p15:clr>
+        </p15:guide>
+      </p15:sldGuideLst>
+    </p:ext>
+  </p:extLst>
 </p:presentation>
 </file>
 
 <file path=ppt/notesMasters/notesMaster1.xml><?xml version="1.0" encoding="utf-8"?>
-<p:notesMaster xmlns:a="http://schemas.openxmlformats.org/drawingml/2006/main" xmlns:p="http://schemas.openxmlformats.org/presentationml/2006/main" xmlns:r="http://schemas.openxmlformats.org/officeDocument/2006/relationships">
+<p:notesMaster xmlns:a="http://schemas.openxmlformats.org/drawingml/2006/main" xmlns:r="http://schemas.openxmlformats.org/officeDocument/2006/relationships" xmlns:p="http://schemas.openxmlformats.org/presentationml/2006/main">
   <p:cSld>
     <p:bg>
       <p:bgRef idx="1001">
@@ -141,241 +160,16 @@
           <a:chExt cx="0" cy="0"/>
         </a:xfrm>
       </p:grpSpPr>
-      <p:sp>
-        <p:nvSpPr>
-          <p:cNvPr id="2" name="Header Placeholder 1"/>
-          <p:cNvSpPr>
-            <a:spLocks noGrp="1"/>
-          </p:cNvSpPr>
-          <p:nvPr>
-            <p:ph type="hdr" sz="quarter"/>
-          </p:nvPr>
-        </p:nvSpPr>
-        <p:spPr>
-          <a:xfrm>
-            <a:off x="0" y="0"/>
-            <a:ext cx="2971800" cy="457200"/>
-          </a:xfrm>
-          <a:prstGeom prst="rect">
-            <a:avLst/>
-          </a:prstGeom>
-        </p:spPr>
-        <p:txBody>
-          <a:bodyPr vert="horz" lIns="91440" tIns="45720" rIns="91440" bIns="45720" rtlCol="0"/>
-          <a:lstStyle>
-            <a:lvl1pPr algn="l">
-              <a:defRPr sz="1200"/>
-            </a:lvl1pPr>
-          </a:lstStyle>
-          <a:p>
-            <a:endParaRPr lang="en-US"/>
-          </a:p>
-        </p:txBody>
-      </p:sp>
-      <p:sp>
-        <p:nvSpPr>
-          <p:cNvPr id="3" name="Date Placeholder 2"/>
-          <p:cNvSpPr>
-            <a:spLocks noGrp="1"/>
-          </p:cNvSpPr>
-          <p:nvPr>
-            <p:ph type="dt" idx="1"/>
-          </p:nvPr>
-        </p:nvSpPr>
-        <p:spPr>
-          <a:xfrm>
-            <a:off x="3884613" y="0"/>
-            <a:ext cx="2971800" cy="457200"/>
-          </a:xfrm>
-          <a:prstGeom prst="rect">
-            <a:avLst/>
-          </a:prstGeom>
-        </p:spPr>
-        <p:txBody>
-          <a:bodyPr vert="horz" lIns="91440" tIns="45720" rIns="91440" bIns="45720" rtlCol="0"/>
-          <a:lstStyle>
-            <a:lvl1pPr algn="r">
-              <a:defRPr sz="1200"/>
-            </a:lvl1pPr>
-          </a:lstStyle>
-          <a:p>
-            <a:fld id="{0F89C1C7-3DCD-1040-A9CF-14679D8B5DDD}" type="datetimeFigureOut">
-              <a:rPr lang="en-US" smtClean="0"/>
-              <a:t>10/17/16</a:t>
-            </a:fld>
-            <a:endParaRPr lang="en-US"/>
-          </a:p>
-        </p:txBody>
-      </p:sp>
-      <p:sp>
-        <p:nvSpPr>
-          <p:cNvPr id="4" name="Slide Image Placeholder 3"/>
-          <p:cNvSpPr>
-            <a:spLocks noGrp="1" noRot="1" noChangeAspect="1"/>
-          </p:cNvSpPr>
-          <p:nvPr>
-            <p:ph type="sldImg" idx="2"/>
-          </p:nvPr>
-        </p:nvSpPr>
-        <p:spPr>
-          <a:xfrm>
-            <a:off x="1143000" y="685800"/>
-            <a:ext cx="4572000" cy="3429000"/>
-          </a:xfrm>
-          <a:prstGeom prst="rect">
-            <a:avLst/>
-          </a:prstGeom>
-          <a:noFill/>
-          <a:ln w="12700">
-            <a:solidFill>
-              <a:prstClr val="black"/>
-            </a:solidFill>
-          </a:ln>
-        </p:spPr>
-        <p:txBody>
-          <a:bodyPr vert="horz" lIns="91440" tIns="45720" rIns="91440" bIns="45720" rtlCol="0" anchor="ctr"/>
-          <a:lstStyle/>
-          <a:p>
-            <a:endParaRPr lang="en-US"/>
-          </a:p>
-        </p:txBody>
-      </p:sp>
-      <p:sp>
-        <p:nvSpPr>
-          <p:cNvPr id="5" name="Notes Placeholder 4"/>
-          <p:cNvSpPr>
-            <a:spLocks noGrp="1"/>
-          </p:cNvSpPr>
-          <p:nvPr>
-            <p:ph type="body" sz="quarter" idx="3"/>
-          </p:nvPr>
-        </p:nvSpPr>
-        <p:spPr>
-          <a:xfrm>
-            <a:off x="685800" y="4343400"/>
-            <a:ext cx="5486400" cy="4114800"/>
-          </a:xfrm>
-          <a:prstGeom prst="rect">
-            <a:avLst/>
-          </a:prstGeom>
-        </p:spPr>
-        <p:txBody>
-          <a:bodyPr vert="horz" lIns="91440" tIns="45720" rIns="91440" bIns="45720" rtlCol="0"/>
-          <a:lstStyle/>
-          <a:p>
-            <a:pPr lvl="0"/>
-            <a:r>
-              <a:rPr lang="en-US" smtClean="0"/>
-              <a:t>Click to edit Master text styles</a:t>
-            </a:r>
-          </a:p>
-          <a:p>
-            <a:pPr lvl="1"/>
-            <a:r>
-              <a:rPr lang="en-US" smtClean="0"/>
-              <a:t>Second level</a:t>
-            </a:r>
-          </a:p>
-          <a:p>
-            <a:pPr lvl="2"/>
-            <a:r>
-              <a:rPr lang="en-US" smtClean="0"/>
-              <a:t>Third level</a:t>
-            </a:r>
-          </a:p>
-          <a:p>
-            <a:pPr lvl="3"/>
-            <a:r>
-              <a:rPr lang="en-US" smtClean="0"/>
-              <a:t>Fourth level</a:t>
-            </a:r>
-          </a:p>
-          <a:p>
-            <a:pPr lvl="4"/>
-            <a:r>
-              <a:rPr lang="en-US" smtClean="0"/>
-              <a:t>Fifth level</a:t>
-            </a:r>
-            <a:endParaRPr lang="en-US"/>
-          </a:p>
-        </p:txBody>
-      </p:sp>
-      <p:sp>
-        <p:nvSpPr>
-          <p:cNvPr id="6" name="Footer Placeholder 5"/>
-          <p:cNvSpPr>
-            <a:spLocks noGrp="1"/>
-          </p:cNvSpPr>
-          <p:nvPr>
-            <p:ph type="ftr" sz="quarter" idx="4"/>
-          </p:nvPr>
-        </p:nvSpPr>
-        <p:spPr>
-          <a:xfrm>
-            <a:off x="0" y="8685213"/>
-            <a:ext cx="2971800" cy="457200"/>
-          </a:xfrm>
-          <a:prstGeom prst="rect">
-            <a:avLst/>
-          </a:prstGeom>
-        </p:spPr>
-        <p:txBody>
-          <a:bodyPr vert="horz" lIns="91440" tIns="45720" rIns="91440" bIns="45720" rtlCol="0" anchor="b"/>
-          <a:lstStyle>
-            <a:lvl1pPr algn="l">
-              <a:defRPr sz="1200"/>
-            </a:lvl1pPr>
-          </a:lstStyle>
-          <a:p>
-            <a:endParaRPr lang="en-US"/>
-          </a:p>
-        </p:txBody>
-      </p:sp>
-      <p:sp>
-        <p:nvSpPr>
-          <p:cNvPr id="7" name="Slide Number Placeholder 6"/>
-          <p:cNvSpPr>
-            <a:spLocks noGrp="1"/>
-          </p:cNvSpPr>
-          <p:nvPr>
-            <p:ph type="sldNum" sz="quarter" idx="5"/>
-          </p:nvPr>
-        </p:nvSpPr>
-        <p:spPr>
-          <a:xfrm>
-            <a:off x="3884613" y="8685213"/>
-            <a:ext cx="2971800" cy="457200"/>
-          </a:xfrm>
-          <a:prstGeom prst="rect">
-            <a:avLst/>
-          </a:prstGeom>
-        </p:spPr>
-        <p:txBody>
-          <a:bodyPr vert="horz" lIns="91440" tIns="45720" rIns="91440" bIns="45720" rtlCol="0" anchor="b"/>
-          <a:lstStyle>
-            <a:lvl1pPr algn="r">
-              <a:defRPr sz="1200"/>
-            </a:lvl1pPr>
-          </a:lstStyle>
-          <a:p>
-            <a:fld id="{BB5E49A5-4136-284D-997B-48E1D791AD67}" type="slidenum">
-              <a:rPr lang="en-US" smtClean="0"/>
-              <a:t>‹#›</a:t>
-            </a:fld>
-            <a:endParaRPr lang="en-US"/>
-          </a:p>
-        </p:txBody>
-      </p:sp>
     </p:spTree>
     <p:extLst>
       <p:ext uri="{BB962C8B-B14F-4D97-AF65-F5344CB8AC3E}">
-        <p14:creationId xmlns:p14="http://schemas.microsoft.com/office/powerpoint/2010/main" val="2623252185"/>
+        <p14:creationId xmlns:p14="http://schemas.microsoft.com/office/powerpoint/2010/main" val="2757001507"/>
       </p:ext>
     </p:extLst>
   </p:cSld>
   <p:clrMap bg1="lt1" tx1="dk1" bg2="lt2" tx2="dk2" accent1="accent1" accent2="accent2" accent3="accent3" accent4="accent4" accent5="accent5" accent6="accent6" hlink="hlink" folHlink="folHlink"/>
   <p:notesStyle>
-    <a:lvl1pPr marL="0" algn="l" defTabSz="457200" rtl="0" eaLnBrk="1" latinLnBrk="0" hangingPunct="1">
+    <a:lvl1pPr marL="0" algn="l" defTabSz="914400" rtl="0" eaLnBrk="1" latinLnBrk="0" hangingPunct="1">
       <a:defRPr sz="1200" kern="1200">
         <a:solidFill>
           <a:schemeClr val="tx1"/>
@@ -385,7 +179,7 @@
         <a:cs typeface="+mn-cs"/>
       </a:defRPr>
     </a:lvl1pPr>
-    <a:lvl2pPr marL="457200" algn="l" defTabSz="457200" rtl="0" eaLnBrk="1" latinLnBrk="0" hangingPunct="1">
+    <a:lvl2pPr marL="457200" algn="l" defTabSz="914400" rtl="0" eaLnBrk="1" latinLnBrk="0" hangingPunct="1">
       <a:defRPr sz="1200" kern="1200">
         <a:solidFill>
           <a:schemeClr val="tx1"/>
@@ -395,7 +189,7 @@
         <a:cs typeface="+mn-cs"/>
       </a:defRPr>
     </a:lvl2pPr>
-    <a:lvl3pPr marL="914400" algn="l" defTabSz="457200" rtl="0" eaLnBrk="1" latinLnBrk="0" hangingPunct="1">
+    <a:lvl3pPr marL="914400" algn="l" defTabSz="914400" rtl="0" eaLnBrk="1" latinLnBrk="0" hangingPunct="1">
       <a:defRPr sz="1200" kern="1200">
         <a:solidFill>
           <a:schemeClr val="tx1"/>
@@ -405,7 +199,7 @@
         <a:cs typeface="+mn-cs"/>
       </a:defRPr>
     </a:lvl3pPr>
-    <a:lvl4pPr marL="1371600" algn="l" defTabSz="457200" rtl="0" eaLnBrk="1" latinLnBrk="0" hangingPunct="1">
+    <a:lvl4pPr marL="1371600" algn="l" defTabSz="914400" rtl="0" eaLnBrk="1" latinLnBrk="0" hangingPunct="1">
       <a:defRPr sz="1200" kern="1200">
         <a:solidFill>
           <a:schemeClr val="tx1"/>
@@ -415,7 +209,7 @@
         <a:cs typeface="+mn-cs"/>
       </a:defRPr>
     </a:lvl4pPr>
-    <a:lvl5pPr marL="1828800" algn="l" defTabSz="457200" rtl="0" eaLnBrk="1" latinLnBrk="0" hangingPunct="1">
+    <a:lvl5pPr marL="1828800" algn="l" defTabSz="914400" rtl="0" eaLnBrk="1" latinLnBrk="0" hangingPunct="1">
       <a:defRPr sz="1200" kern="1200">
         <a:solidFill>
           <a:schemeClr val="tx1"/>
@@ -425,7 +219,7 @@
         <a:cs typeface="+mn-cs"/>
       </a:defRPr>
     </a:lvl5pPr>
-    <a:lvl6pPr marL="2286000" algn="l" defTabSz="457200" rtl="0" eaLnBrk="1" latinLnBrk="0" hangingPunct="1">
+    <a:lvl6pPr marL="2286000" algn="l" defTabSz="914400" rtl="0" eaLnBrk="1" latinLnBrk="0" hangingPunct="1">
       <a:defRPr sz="1200" kern="1200">
         <a:solidFill>
           <a:schemeClr val="tx1"/>
@@ -435,7 +229,7 @@
         <a:cs typeface="+mn-cs"/>
       </a:defRPr>
     </a:lvl6pPr>
-    <a:lvl7pPr marL="2743200" algn="l" defTabSz="457200" rtl="0" eaLnBrk="1" latinLnBrk="0" hangingPunct="1">
+    <a:lvl7pPr marL="2743200" algn="l" defTabSz="914400" rtl="0" eaLnBrk="1" latinLnBrk="0" hangingPunct="1">
       <a:defRPr sz="1200" kern="1200">
         <a:solidFill>
           <a:schemeClr val="tx1"/>
@@ -445,7 +239,7 @@
         <a:cs typeface="+mn-cs"/>
       </a:defRPr>
     </a:lvl7pPr>
-    <a:lvl8pPr marL="3200400" algn="l" defTabSz="457200" rtl="0" eaLnBrk="1" latinLnBrk="0" hangingPunct="1">
+    <a:lvl8pPr marL="3200400" algn="l" defTabSz="914400" rtl="0" eaLnBrk="1" latinLnBrk="0" hangingPunct="1">
       <a:defRPr sz="1200" kern="1200">
         <a:solidFill>
           <a:schemeClr val="tx1"/>
@@ -455,7 +249,7 @@
         <a:cs typeface="+mn-cs"/>
       </a:defRPr>
     </a:lvl8pPr>
-    <a:lvl9pPr marL="3657600" algn="l" defTabSz="457200" rtl="0" eaLnBrk="1" latinLnBrk="0" hangingPunct="1">
+    <a:lvl9pPr marL="3657600" algn="l" defTabSz="914400" rtl="0" eaLnBrk="1" latinLnBrk="0" hangingPunct="1">
       <a:defRPr sz="1200" kern="1200">
         <a:solidFill>
           <a:schemeClr val="tx1"/>
@@ -470,7 +264,7 @@
 </file>
 
 <file path=ppt/notesSlides/notesSlide1.xml><?xml version="1.0" encoding="utf-8"?>
-<p:notes xmlns:a="http://schemas.openxmlformats.org/drawingml/2006/main" xmlns:p="http://schemas.openxmlformats.org/presentationml/2006/main" xmlns:r="http://schemas.openxmlformats.org/officeDocument/2006/relationships">
+<p:notes xmlns:a="http://schemas.openxmlformats.org/drawingml/2006/main" xmlns:r="http://schemas.openxmlformats.org/officeDocument/2006/relationships" xmlns:p="http://schemas.openxmlformats.org/presentationml/2006/main">
   <p:cSld>
     <p:spTree>
       <p:nvGrpSpPr>
@@ -490,7 +284,7 @@
         <p:nvSpPr>
           <p:cNvPr id="2" name="Slide Image Placeholder 1"/>
           <p:cNvSpPr>
-            <a:spLocks noGrp="1"/>
+            <a:spLocks noGrp="1" noRot="1" noChangeAspect="1"/>
           </p:cNvSpPr>
           <p:nvPr>
             <p:ph type="sldImg" idx="2"/>
@@ -505,7 +299,7 @@
             <a:spLocks noGrp="1"/>
           </p:cNvSpPr>
           <p:nvPr>
-            <p:ph type="body" idx="3" sz="quarter"/>
+            <p:ph type="body" sz="quarter" idx="3"/>
           </p:nvPr>
         </p:nvSpPr>
         <p:spPr/>
@@ -514,6 +308,7 @@
           <a:lstStyle/>
           <a:p>
             <a:r>
+              <a:rPr dirty="0"/>
               <a:t>Cover — loops before class. The one-line bio must be filled before class (a blank cover line is a credibility leak). Point at the Lesson-1 outcome image in the first 30 seconds — "That's a student from the last cohort, end of their first lesson. Next session, that's you."</a:t>
             </a:r>
           </a:p>
@@ -526,7 +321,7 @@
             <a:spLocks noGrp="1"/>
           </p:cNvSpPr>
           <p:nvPr>
-            <p:ph type="sldNum" idx="5" sz="quarter"/>
+            <p:ph type="sldNum" sz="quarter" idx="5"/>
           </p:nvPr>
         </p:nvSpPr>
         <p:spPr/>
@@ -540,7 +335,7 @@
 </file>
 
 <file path=ppt/notesSlides/notesSlide10.xml><?xml version="1.0" encoding="utf-8"?>
-<p:notes xmlns:a="http://schemas.openxmlformats.org/drawingml/2006/main" xmlns:p="http://schemas.openxmlformats.org/presentationml/2006/main" xmlns:r="http://schemas.openxmlformats.org/officeDocument/2006/relationships">
+<p:notes xmlns:a="http://schemas.openxmlformats.org/drawingml/2006/main" xmlns:r="http://schemas.openxmlformats.org/officeDocument/2006/relationships" xmlns:p="http://schemas.openxmlformats.org/presentationml/2006/main">
   <p:cSld>
     <p:spTree>
       <p:nvGrpSpPr>
@@ -560,7 +355,7 @@
         <p:nvSpPr>
           <p:cNvPr id="2" name="Slide Image Placeholder 1"/>
           <p:cNvSpPr>
-            <a:spLocks noGrp="1"/>
+            <a:spLocks noGrp="1" noRot="1" noChangeAspect="1"/>
           </p:cNvSpPr>
           <p:nvPr>
             <p:ph type="sldImg" idx="2"/>
@@ -575,7 +370,7 @@
             <a:spLocks noGrp="1"/>
           </p:cNvSpPr>
           <p:nvPr>
-            <p:ph type="body" idx="3" sz="quarter"/>
+            <p:ph type="body" sz="quarter" idx="3"/>
           </p:nvPr>
         </p:nvSpPr>
         <p:spPr/>
@@ -596,7 +391,7 @@
             <a:spLocks noGrp="1"/>
           </p:cNvSpPr>
           <p:nvPr>
-            <p:ph type="sldNum" idx="5" sz="quarter"/>
+            <p:ph type="sldNum" sz="quarter" idx="5"/>
           </p:nvPr>
         </p:nvSpPr>
         <p:spPr/>
@@ -610,7 +405,7 @@
 </file>
 
 <file path=ppt/notesSlides/notesSlide11.xml><?xml version="1.0" encoding="utf-8"?>
-<p:notes xmlns:a="http://schemas.openxmlformats.org/drawingml/2006/main" xmlns:p="http://schemas.openxmlformats.org/presentationml/2006/main" xmlns:r="http://schemas.openxmlformats.org/officeDocument/2006/relationships">
+<p:notes xmlns:a="http://schemas.openxmlformats.org/drawingml/2006/main" xmlns:r="http://schemas.openxmlformats.org/officeDocument/2006/relationships" xmlns:p="http://schemas.openxmlformats.org/presentationml/2006/main">
   <p:cSld>
     <p:spTree>
       <p:nvGrpSpPr>
@@ -630,7 +425,7 @@
         <p:nvSpPr>
           <p:cNvPr id="2" name="Slide Image Placeholder 1"/>
           <p:cNvSpPr>
-            <a:spLocks noGrp="1"/>
+            <a:spLocks noGrp="1" noRot="1" noChangeAspect="1"/>
           </p:cNvSpPr>
           <p:nvPr>
             <p:ph type="sldImg" idx="2"/>
@@ -645,7 +440,7 @@
             <a:spLocks noGrp="1"/>
           </p:cNvSpPr>
           <p:nvPr>
-            <p:ph type="body" idx="3" sz="quarter"/>
+            <p:ph type="body" sz="quarter" idx="3"/>
           </p:nvPr>
         </p:nvSpPr>
         <p:spPr/>
@@ -666,7 +461,7 @@
             <a:spLocks noGrp="1"/>
           </p:cNvSpPr>
           <p:nvPr>
-            <p:ph type="sldNum" idx="5" sz="quarter"/>
+            <p:ph type="sldNum" sz="quarter" idx="5"/>
           </p:nvPr>
         </p:nvSpPr>
         <p:spPr/>
@@ -680,7 +475,7 @@
 </file>
 
 <file path=ppt/notesSlides/notesSlide12.xml><?xml version="1.0" encoding="utf-8"?>
-<p:notes xmlns:a="http://schemas.openxmlformats.org/drawingml/2006/main" xmlns:p="http://schemas.openxmlformats.org/presentationml/2006/main" xmlns:r="http://schemas.openxmlformats.org/officeDocument/2006/relationships">
+<p:notes xmlns:a="http://schemas.openxmlformats.org/drawingml/2006/main" xmlns:r="http://schemas.openxmlformats.org/officeDocument/2006/relationships" xmlns:p="http://schemas.openxmlformats.org/presentationml/2006/main">
   <p:cSld>
     <p:spTree>
       <p:nvGrpSpPr>
@@ -700,7 +495,7 @@
         <p:nvSpPr>
           <p:cNvPr id="2" name="Slide Image Placeholder 1"/>
           <p:cNvSpPr>
-            <a:spLocks noGrp="1"/>
+            <a:spLocks noGrp="1" noRot="1" noChangeAspect="1"/>
           </p:cNvSpPr>
           <p:nvPr>
             <p:ph type="sldImg" idx="2"/>
@@ -715,7 +510,7 @@
             <a:spLocks noGrp="1"/>
           </p:cNvSpPr>
           <p:nvPr>
-            <p:ph type="body" idx="3" sz="quarter"/>
+            <p:ph type="body" sz="quarter" idx="3"/>
           </p:nvPr>
         </p:nvSpPr>
         <p:spPr/>
@@ -736,7 +531,7 @@
             <a:spLocks noGrp="1"/>
           </p:cNvSpPr>
           <p:nvPr>
-            <p:ph type="sldNum" idx="5" sz="quarter"/>
+            <p:ph type="sldNum" sz="quarter" idx="5"/>
           </p:nvPr>
         </p:nvSpPr>
         <p:spPr/>
@@ -750,7 +545,7 @@
 </file>
 
 <file path=ppt/notesSlides/notesSlide13.xml><?xml version="1.0" encoding="utf-8"?>
-<p:notes xmlns:a="http://schemas.openxmlformats.org/drawingml/2006/main" xmlns:p="http://schemas.openxmlformats.org/presentationml/2006/main" xmlns:r="http://schemas.openxmlformats.org/officeDocument/2006/relationships">
+<p:notes xmlns:a="http://schemas.openxmlformats.org/drawingml/2006/main" xmlns:r="http://schemas.openxmlformats.org/officeDocument/2006/relationships" xmlns:p="http://schemas.openxmlformats.org/presentationml/2006/main">
   <p:cSld>
     <p:spTree>
       <p:nvGrpSpPr>
@@ -770,7 +565,7 @@
         <p:nvSpPr>
           <p:cNvPr id="2" name="Slide Image Placeholder 1"/>
           <p:cNvSpPr>
-            <a:spLocks noGrp="1"/>
+            <a:spLocks noGrp="1" noRot="1" noChangeAspect="1"/>
           </p:cNvSpPr>
           <p:nvPr>
             <p:ph type="sldImg" idx="2"/>
@@ -785,7 +580,7 @@
             <a:spLocks noGrp="1"/>
           </p:cNvSpPr>
           <p:nvPr>
-            <p:ph type="body" idx="3" sz="quarter"/>
+            <p:ph type="body" sz="quarter" idx="3"/>
           </p:nvPr>
         </p:nvSpPr>
         <p:spPr/>
@@ -806,7 +601,7 @@
             <a:spLocks noGrp="1"/>
           </p:cNvSpPr>
           <p:nvPr>
-            <p:ph type="sldNum" idx="5" sz="quarter"/>
+            <p:ph type="sldNum" sz="quarter" idx="5"/>
           </p:nvPr>
         </p:nvSpPr>
         <p:spPr/>
@@ -820,7 +615,7 @@
 </file>
 
 <file path=ppt/notesSlides/notesSlide2.xml><?xml version="1.0" encoding="utf-8"?>
-<p:notes xmlns:a="http://schemas.openxmlformats.org/drawingml/2006/main" xmlns:p="http://schemas.openxmlformats.org/presentationml/2006/main" xmlns:r="http://schemas.openxmlformats.org/officeDocument/2006/relationships">
+<p:notes xmlns:a="http://schemas.openxmlformats.org/drawingml/2006/main" xmlns:r="http://schemas.openxmlformats.org/officeDocument/2006/relationships" xmlns:p="http://schemas.openxmlformats.org/presentationml/2006/main">
   <p:cSld>
     <p:spTree>
       <p:nvGrpSpPr>
@@ -840,7 +635,7 @@
         <p:nvSpPr>
           <p:cNvPr id="2" name="Slide Image Placeholder 1"/>
           <p:cNvSpPr>
-            <a:spLocks noGrp="1"/>
+            <a:spLocks noGrp="1" noRot="1" noChangeAspect="1"/>
           </p:cNvSpPr>
           <p:nvPr>
             <p:ph type="sldImg" idx="2"/>
@@ -855,7 +650,7 @@
             <a:spLocks noGrp="1"/>
           </p:cNvSpPr>
           <p:nvPr>
-            <p:ph type="body" idx="3" sz="quarter"/>
+            <p:ph type="body" sz="quarter" idx="3"/>
           </p:nvPr>
         </p:nvSpPr>
         <p:spPr/>
@@ -876,7 +671,7 @@
             <a:spLocks noGrp="1"/>
           </p:cNvSpPr>
           <p:nvPr>
-            <p:ph type="sldNum" idx="5" sz="quarter"/>
+            <p:ph type="sldNum" sz="quarter" idx="5"/>
           </p:nvPr>
         </p:nvSpPr>
         <p:spPr/>
@@ -890,7 +685,7 @@
 </file>
 
 <file path=ppt/notesSlides/notesSlide3.xml><?xml version="1.0" encoding="utf-8"?>
-<p:notes xmlns:a="http://schemas.openxmlformats.org/drawingml/2006/main" xmlns:p="http://schemas.openxmlformats.org/presentationml/2006/main" xmlns:r="http://schemas.openxmlformats.org/officeDocument/2006/relationships">
+<p:notes xmlns:a="http://schemas.openxmlformats.org/drawingml/2006/main" xmlns:r="http://schemas.openxmlformats.org/officeDocument/2006/relationships" xmlns:p="http://schemas.openxmlformats.org/presentationml/2006/main">
   <p:cSld>
     <p:spTree>
       <p:nvGrpSpPr>
@@ -910,7 +705,7 @@
         <p:nvSpPr>
           <p:cNvPr id="2" name="Slide Image Placeholder 1"/>
           <p:cNvSpPr>
-            <a:spLocks noGrp="1"/>
+            <a:spLocks noGrp="1" noRot="1" noChangeAspect="1"/>
           </p:cNvSpPr>
           <p:nvPr>
             <p:ph type="sldImg" idx="2"/>
@@ -925,7 +720,7 @@
             <a:spLocks noGrp="1"/>
           </p:cNvSpPr>
           <p:nvPr>
-            <p:ph type="body" idx="3" sz="quarter"/>
+            <p:ph type="body" sz="quarter" idx="3"/>
           </p:nvPr>
         </p:nvSpPr>
         <p:spPr/>
@@ -946,7 +741,7 @@
             <a:spLocks noGrp="1"/>
           </p:cNvSpPr>
           <p:nvPr>
-            <p:ph type="sldNum" idx="5" sz="quarter"/>
+            <p:ph type="sldNum" sz="quarter" idx="5"/>
           </p:nvPr>
         </p:nvSpPr>
         <p:spPr/>
@@ -960,7 +755,7 @@
 </file>
 
 <file path=ppt/notesSlides/notesSlide4.xml><?xml version="1.0" encoding="utf-8"?>
-<p:notes xmlns:a="http://schemas.openxmlformats.org/drawingml/2006/main" xmlns:p="http://schemas.openxmlformats.org/presentationml/2006/main" xmlns:r="http://schemas.openxmlformats.org/officeDocument/2006/relationships">
+<p:notes xmlns:a="http://schemas.openxmlformats.org/drawingml/2006/main" xmlns:r="http://schemas.openxmlformats.org/officeDocument/2006/relationships" xmlns:p="http://schemas.openxmlformats.org/presentationml/2006/main">
   <p:cSld>
     <p:spTree>
       <p:nvGrpSpPr>
@@ -980,7 +775,7 @@
         <p:nvSpPr>
           <p:cNvPr id="2" name="Slide Image Placeholder 1"/>
           <p:cNvSpPr>
-            <a:spLocks noGrp="1"/>
+            <a:spLocks noGrp="1" noRot="1" noChangeAspect="1"/>
           </p:cNvSpPr>
           <p:nvPr>
             <p:ph type="sldImg" idx="2"/>
@@ -995,7 +790,7 @@
             <a:spLocks noGrp="1"/>
           </p:cNvSpPr>
           <p:nvPr>
-            <p:ph type="body" idx="3" sz="quarter"/>
+            <p:ph type="body" sz="quarter" idx="3"/>
           </p:nvPr>
         </p:nvSpPr>
         <p:spPr/>
@@ -1016,7 +811,7 @@
             <a:spLocks noGrp="1"/>
           </p:cNvSpPr>
           <p:nvPr>
-            <p:ph type="sldNum" idx="5" sz="quarter"/>
+            <p:ph type="sldNum" sz="quarter" idx="5"/>
           </p:nvPr>
         </p:nvSpPr>
         <p:spPr/>
@@ -1030,7 +825,7 @@
 </file>
 
 <file path=ppt/notesSlides/notesSlide5.xml><?xml version="1.0" encoding="utf-8"?>
-<p:notes xmlns:a="http://schemas.openxmlformats.org/drawingml/2006/main" xmlns:p="http://schemas.openxmlformats.org/presentationml/2006/main" xmlns:r="http://schemas.openxmlformats.org/officeDocument/2006/relationships">
+<p:notes xmlns:a="http://schemas.openxmlformats.org/drawingml/2006/main" xmlns:r="http://schemas.openxmlformats.org/officeDocument/2006/relationships" xmlns:p="http://schemas.openxmlformats.org/presentationml/2006/main">
   <p:cSld>
     <p:spTree>
       <p:nvGrpSpPr>
@@ -1050,7 +845,7 @@
         <p:nvSpPr>
           <p:cNvPr id="2" name="Slide Image Placeholder 1"/>
           <p:cNvSpPr>
-            <a:spLocks noGrp="1"/>
+            <a:spLocks noGrp="1" noRot="1" noChangeAspect="1"/>
           </p:cNvSpPr>
           <p:nvPr>
             <p:ph type="sldImg" idx="2"/>
@@ -1065,7 +860,7 @@
             <a:spLocks noGrp="1"/>
           </p:cNvSpPr>
           <p:nvPr>
-            <p:ph type="body" idx="3" sz="quarter"/>
+            <p:ph type="body" sz="quarter" idx="3"/>
           </p:nvPr>
         </p:nvSpPr>
         <p:spPr/>
@@ -1086,7 +881,7 @@
             <a:spLocks noGrp="1"/>
           </p:cNvSpPr>
           <p:nvPr>
-            <p:ph type="sldNum" idx="5" sz="quarter"/>
+            <p:ph type="sldNum" sz="quarter" idx="5"/>
           </p:nvPr>
         </p:nvSpPr>
         <p:spPr/>
@@ -1100,7 +895,7 @@
 </file>
 
 <file path=ppt/notesSlides/notesSlide6.xml><?xml version="1.0" encoding="utf-8"?>
-<p:notes xmlns:a="http://schemas.openxmlformats.org/drawingml/2006/main" xmlns:p="http://schemas.openxmlformats.org/presentationml/2006/main" xmlns:r="http://schemas.openxmlformats.org/officeDocument/2006/relationships">
+<p:notes xmlns:a="http://schemas.openxmlformats.org/drawingml/2006/main" xmlns:r="http://schemas.openxmlformats.org/officeDocument/2006/relationships" xmlns:p="http://schemas.openxmlformats.org/presentationml/2006/main">
   <p:cSld>
     <p:spTree>
       <p:nvGrpSpPr>
@@ -1120,7 +915,7 @@
         <p:nvSpPr>
           <p:cNvPr id="2" name="Slide Image Placeholder 1"/>
           <p:cNvSpPr>
-            <a:spLocks noGrp="1"/>
+            <a:spLocks noGrp="1" noRot="1" noChangeAspect="1"/>
           </p:cNvSpPr>
           <p:nvPr>
             <p:ph type="sldImg" idx="2"/>
@@ -1135,7 +930,7 @@
             <a:spLocks noGrp="1"/>
           </p:cNvSpPr>
           <p:nvPr>
-            <p:ph type="body" idx="3" sz="quarter"/>
+            <p:ph type="body" sz="quarter" idx="3"/>
           </p:nvPr>
         </p:nvSpPr>
         <p:spPr/>
@@ -1156,7 +951,7 @@
             <a:spLocks noGrp="1"/>
           </p:cNvSpPr>
           <p:nvPr>
-            <p:ph type="sldNum" idx="5" sz="quarter"/>
+            <p:ph type="sldNum" sz="quarter" idx="5"/>
           </p:nvPr>
         </p:nvSpPr>
         <p:spPr/>
@@ -1170,7 +965,7 @@
 </file>
 
 <file path=ppt/notesSlides/notesSlide7.xml><?xml version="1.0" encoding="utf-8"?>
-<p:notes xmlns:a="http://schemas.openxmlformats.org/drawingml/2006/main" xmlns:p="http://schemas.openxmlformats.org/presentationml/2006/main" xmlns:r="http://schemas.openxmlformats.org/officeDocument/2006/relationships">
+<p:notes xmlns:a="http://schemas.openxmlformats.org/drawingml/2006/main" xmlns:r="http://schemas.openxmlformats.org/officeDocument/2006/relationships" xmlns:p="http://schemas.openxmlformats.org/presentationml/2006/main">
   <p:cSld>
     <p:spTree>
       <p:nvGrpSpPr>
@@ -1190,7 +985,7 @@
         <p:nvSpPr>
           <p:cNvPr id="2" name="Slide Image Placeholder 1"/>
           <p:cNvSpPr>
-            <a:spLocks noGrp="1"/>
+            <a:spLocks noGrp="1" noRot="1" noChangeAspect="1"/>
           </p:cNvSpPr>
           <p:nvPr>
             <p:ph type="sldImg" idx="2"/>
@@ -1205,7 +1000,7 @@
             <a:spLocks noGrp="1"/>
           </p:cNvSpPr>
           <p:nvPr>
-            <p:ph type="body" idx="3" sz="quarter"/>
+            <p:ph type="body" sz="quarter" idx="3"/>
           </p:nvPr>
         </p:nvSpPr>
         <p:spPr/>
@@ -1226,7 +1021,7 @@
             <a:spLocks noGrp="1"/>
           </p:cNvSpPr>
           <p:nvPr>
-            <p:ph type="sldNum" idx="5" sz="quarter"/>
+            <p:ph type="sldNum" sz="quarter" idx="5"/>
           </p:nvPr>
         </p:nvSpPr>
         <p:spPr/>
@@ -1240,7 +1035,7 @@
 </file>
 
 <file path=ppt/notesSlides/notesSlide8.xml><?xml version="1.0" encoding="utf-8"?>
-<p:notes xmlns:a="http://schemas.openxmlformats.org/drawingml/2006/main" xmlns:p="http://schemas.openxmlformats.org/presentationml/2006/main" xmlns:r="http://schemas.openxmlformats.org/officeDocument/2006/relationships">
+<p:notes xmlns:a="http://schemas.openxmlformats.org/drawingml/2006/main" xmlns:r="http://schemas.openxmlformats.org/officeDocument/2006/relationships" xmlns:p="http://schemas.openxmlformats.org/presentationml/2006/main">
   <p:cSld>
     <p:spTree>
       <p:nvGrpSpPr>
@@ -1260,7 +1055,7 @@
         <p:nvSpPr>
           <p:cNvPr id="2" name="Slide Image Placeholder 1"/>
           <p:cNvSpPr>
-            <a:spLocks noGrp="1"/>
+            <a:spLocks noGrp="1" noRot="1" noChangeAspect="1"/>
           </p:cNvSpPr>
           <p:nvPr>
             <p:ph type="sldImg" idx="2"/>
@@ -1275,7 +1070,7 @@
             <a:spLocks noGrp="1"/>
           </p:cNvSpPr>
           <p:nvPr>
-            <p:ph type="body" idx="3" sz="quarter"/>
+            <p:ph type="body" sz="quarter" idx="3"/>
           </p:nvPr>
         </p:nvSpPr>
         <p:spPr/>
@@ -1296,7 +1091,7 @@
             <a:spLocks noGrp="1"/>
           </p:cNvSpPr>
           <p:nvPr>
-            <p:ph type="sldNum" idx="5" sz="quarter"/>
+            <p:ph type="sldNum" sz="quarter" idx="5"/>
           </p:nvPr>
         </p:nvSpPr>
         <p:spPr/>
@@ -1310,7 +1105,7 @@
 </file>
 
 <file path=ppt/notesSlides/notesSlide9.xml><?xml version="1.0" encoding="utf-8"?>
-<p:notes xmlns:a="http://schemas.openxmlformats.org/drawingml/2006/main" xmlns:p="http://schemas.openxmlformats.org/presentationml/2006/main" xmlns:r="http://schemas.openxmlformats.org/officeDocument/2006/relationships">
+<p:notes xmlns:a="http://schemas.openxmlformats.org/drawingml/2006/main" xmlns:r="http://schemas.openxmlformats.org/officeDocument/2006/relationships" xmlns:p="http://schemas.openxmlformats.org/presentationml/2006/main">
   <p:cSld>
     <p:spTree>
       <p:nvGrpSpPr>
@@ -1330,7 +1125,7 @@
         <p:nvSpPr>
           <p:cNvPr id="2" name="Slide Image Placeholder 1"/>
           <p:cNvSpPr>
-            <a:spLocks noGrp="1"/>
+            <a:spLocks noGrp="1" noRot="1" noChangeAspect="1"/>
           </p:cNvSpPr>
           <p:nvPr>
             <p:ph type="sldImg" idx="2"/>
@@ -1345,7 +1140,7 @@
             <a:spLocks noGrp="1"/>
           </p:cNvSpPr>
           <p:nvPr>
-            <p:ph type="body" idx="3" sz="quarter"/>
+            <p:ph type="body" sz="quarter" idx="3"/>
           </p:nvPr>
         </p:nvSpPr>
         <p:spPr/>
@@ -1366,7 +1161,7 @@
             <a:spLocks noGrp="1"/>
           </p:cNvSpPr>
           <p:nvPr>
-            <p:ph type="sldNum" idx="5" sz="quarter"/>
+            <p:ph type="sldNum" sz="quarter" idx="5"/>
           </p:nvPr>
         </p:nvSpPr>
         <p:spPr/>
@@ -1417,10 +1212,9 @@
           <a:lstStyle/>
           <a:p>
             <a:r>
-              <a:rPr lang="en-US" smtClean="0"/>
+              <a:rPr lang="en-US"/>
               <a:t>Click to edit Master title style</a:t>
             </a:r>
-            <a:endParaRPr lang="en-US"/>
           </a:p>
         </p:txBody>
       </p:sp>
@@ -1536,10 +1330,9 @@
           </a:lstStyle>
           <a:p>
             <a:r>
-              <a:rPr lang="en-US" smtClean="0"/>
+              <a:rPr lang="en-US"/>
               <a:t>Click to edit Master subtitle style</a:t>
             </a:r>
-            <a:endParaRPr lang="en-US"/>
           </a:p>
         </p:txBody>
       </p:sp>
@@ -1560,7 +1353,7 @@
           <a:p>
             <a:fld id="{5BCAD085-E8A6-8845-BD4E-CB4CCA059FC4}" type="datetimeFigureOut">
               <a:rPr lang="en-US" smtClean="0"/>
-              <a:t>1/27/13</a:t>
+              <a:t>9/1/2026</a:t>
             </a:fld>
             <a:endParaRPr lang="en-US"/>
           </a:p>
@@ -1654,10 +1447,9 @@
           <a:lstStyle/>
           <a:p>
             <a:r>
-              <a:rPr lang="en-US" smtClean="0"/>
+              <a:rPr lang="en-US"/>
               <a:t>Click to edit Master title style</a:t>
             </a:r>
-            <a:endParaRPr lang="en-US"/>
           </a:p>
         </p:txBody>
       </p:sp>
@@ -1678,38 +1470,37 @@
           <a:p>
             <a:pPr lvl="0"/>
             <a:r>
-              <a:rPr lang="en-US" smtClean="0"/>
+              <a:rPr lang="en-US"/>
               <a:t>Click to edit Master text styles</a:t>
             </a:r>
           </a:p>
           <a:p>
             <a:pPr lvl="1"/>
             <a:r>
-              <a:rPr lang="en-US" smtClean="0"/>
+              <a:rPr lang="en-US"/>
               <a:t>Second level</a:t>
             </a:r>
           </a:p>
           <a:p>
             <a:pPr lvl="2"/>
             <a:r>
-              <a:rPr lang="en-US" smtClean="0"/>
+              <a:rPr lang="en-US"/>
               <a:t>Third level</a:t>
             </a:r>
           </a:p>
           <a:p>
             <a:pPr lvl="3"/>
             <a:r>
-              <a:rPr lang="en-US" smtClean="0"/>
+              <a:rPr lang="en-US"/>
               <a:t>Fourth level</a:t>
             </a:r>
           </a:p>
           <a:p>
             <a:pPr lvl="4"/>
             <a:r>
-              <a:rPr lang="en-US" smtClean="0"/>
+              <a:rPr lang="en-US"/>
               <a:t>Fifth level</a:t>
             </a:r>
-            <a:endParaRPr lang="en-US"/>
           </a:p>
         </p:txBody>
       </p:sp>
@@ -1730,7 +1521,7 @@
           <a:p>
             <a:fld id="{5BCAD085-E8A6-8845-BD4E-CB4CCA059FC4}" type="datetimeFigureOut">
               <a:rPr lang="en-US" smtClean="0"/>
-              <a:t>1/27/13</a:t>
+              <a:t>9/1/2026</a:t>
             </a:fld>
             <a:endParaRPr lang="en-US"/>
           </a:p>
@@ -1829,10 +1620,9 @@
           <a:lstStyle/>
           <a:p>
             <a:r>
-              <a:rPr lang="en-US" smtClean="0"/>
+              <a:rPr lang="en-US"/>
               <a:t>Click to edit Master title style</a:t>
             </a:r>
-            <a:endParaRPr lang="en-US"/>
           </a:p>
         </p:txBody>
       </p:sp>
@@ -1858,38 +1648,37 @@
           <a:p>
             <a:pPr lvl="0"/>
             <a:r>
-              <a:rPr lang="en-US" smtClean="0"/>
+              <a:rPr lang="en-US"/>
               <a:t>Click to edit Master text styles</a:t>
             </a:r>
           </a:p>
           <a:p>
             <a:pPr lvl="1"/>
             <a:r>
-              <a:rPr lang="en-US" smtClean="0"/>
+              <a:rPr lang="en-US"/>
               <a:t>Second level</a:t>
             </a:r>
           </a:p>
           <a:p>
             <a:pPr lvl="2"/>
             <a:r>
-              <a:rPr lang="en-US" smtClean="0"/>
+              <a:rPr lang="en-US"/>
               <a:t>Third level</a:t>
             </a:r>
           </a:p>
           <a:p>
             <a:pPr lvl="3"/>
             <a:r>
-              <a:rPr lang="en-US" smtClean="0"/>
+              <a:rPr lang="en-US"/>
               <a:t>Fourth level</a:t>
             </a:r>
           </a:p>
           <a:p>
             <a:pPr lvl="4"/>
             <a:r>
-              <a:rPr lang="en-US" smtClean="0"/>
+              <a:rPr lang="en-US"/>
               <a:t>Fifth level</a:t>
             </a:r>
-            <a:endParaRPr lang="en-US"/>
           </a:p>
         </p:txBody>
       </p:sp>
@@ -1910,7 +1699,7 @@
           <a:p>
             <a:fld id="{5BCAD085-E8A6-8845-BD4E-CB4CCA059FC4}" type="datetimeFigureOut">
               <a:rPr lang="en-US" smtClean="0"/>
-              <a:t>1/27/13</a:t>
+              <a:t>9/1/2026</a:t>
             </a:fld>
             <a:endParaRPr lang="en-US"/>
           </a:p>
@@ -2004,10 +1793,9 @@
           <a:lstStyle/>
           <a:p>
             <a:r>
-              <a:rPr lang="en-US" smtClean="0"/>
+              <a:rPr lang="en-US"/>
               <a:t>Click to edit Master title style</a:t>
             </a:r>
-            <a:endParaRPr lang="en-US"/>
           </a:p>
         </p:txBody>
       </p:sp>
@@ -2028,38 +1816,37 @@
           <a:p>
             <a:pPr lvl="0"/>
             <a:r>
-              <a:rPr lang="en-US" smtClean="0"/>
+              <a:rPr lang="en-US"/>
               <a:t>Click to edit Master text styles</a:t>
             </a:r>
           </a:p>
           <a:p>
             <a:pPr lvl="1"/>
             <a:r>
-              <a:rPr lang="en-US" smtClean="0"/>
+              <a:rPr lang="en-US"/>
               <a:t>Second level</a:t>
             </a:r>
           </a:p>
           <a:p>
             <a:pPr lvl="2"/>
             <a:r>
-              <a:rPr lang="en-US" smtClean="0"/>
+              <a:rPr lang="en-US"/>
               <a:t>Third level</a:t>
             </a:r>
           </a:p>
           <a:p>
             <a:pPr lvl="3"/>
             <a:r>
-              <a:rPr lang="en-US" smtClean="0"/>
+              <a:rPr lang="en-US"/>
               <a:t>Fourth level</a:t>
             </a:r>
           </a:p>
           <a:p>
             <a:pPr lvl="4"/>
             <a:r>
-              <a:rPr lang="en-US" smtClean="0"/>
+              <a:rPr lang="en-US"/>
               <a:t>Fifth level</a:t>
             </a:r>
-            <a:endParaRPr lang="en-US"/>
           </a:p>
         </p:txBody>
       </p:sp>
@@ -2080,7 +1867,7 @@
           <a:p>
             <a:fld id="{5BCAD085-E8A6-8845-BD4E-CB4CCA059FC4}" type="datetimeFigureOut">
               <a:rPr lang="en-US" smtClean="0"/>
-              <a:t>1/27/13</a:t>
+              <a:t>9/1/2026</a:t>
             </a:fld>
             <a:endParaRPr lang="en-US"/>
           </a:p>
@@ -2183,10 +1970,9 @@
           </a:lstStyle>
           <a:p>
             <a:r>
-              <a:rPr lang="en-US" smtClean="0"/>
+              <a:rPr lang="en-US"/>
               <a:t>Click to edit Master title style</a:t>
             </a:r>
-            <a:endParaRPr lang="en-US"/>
           </a:p>
         </p:txBody>
       </p:sp>
@@ -2303,7 +2089,7 @@
           <a:p>
             <a:pPr lvl="0"/>
             <a:r>
-              <a:rPr lang="en-US" smtClean="0"/>
+              <a:rPr lang="en-US"/>
               <a:t>Click to edit Master text styles</a:t>
             </a:r>
           </a:p>
@@ -2326,7 +2112,7 @@
           <a:p>
             <a:fld id="{5BCAD085-E8A6-8845-BD4E-CB4CCA059FC4}" type="datetimeFigureOut">
               <a:rPr lang="en-US" smtClean="0"/>
-              <a:t>1/27/13</a:t>
+              <a:t>9/1/2026</a:t>
             </a:fld>
             <a:endParaRPr lang="en-US"/>
           </a:p>
@@ -2420,10 +2206,9 @@
           <a:lstStyle/>
           <a:p>
             <a:r>
-              <a:rPr lang="en-US" smtClean="0"/>
+              <a:rPr lang="en-US"/>
               <a:t>Click to edit Master title style</a:t>
             </a:r>
-            <a:endParaRPr lang="en-US"/>
           </a:p>
         </p:txBody>
       </p:sp>
@@ -2477,38 +2262,37 @@
           <a:p>
             <a:pPr lvl="0"/>
             <a:r>
-              <a:rPr lang="en-US" smtClean="0"/>
+              <a:rPr lang="en-US"/>
               <a:t>Click to edit Master text styles</a:t>
             </a:r>
           </a:p>
           <a:p>
             <a:pPr lvl="1"/>
             <a:r>
-              <a:rPr lang="en-US" smtClean="0"/>
+              <a:rPr lang="en-US"/>
               <a:t>Second level</a:t>
             </a:r>
           </a:p>
           <a:p>
             <a:pPr lvl="2"/>
             <a:r>
-              <a:rPr lang="en-US" smtClean="0"/>
+              <a:rPr lang="en-US"/>
               <a:t>Third level</a:t>
             </a:r>
           </a:p>
           <a:p>
             <a:pPr lvl="3"/>
             <a:r>
-              <a:rPr lang="en-US" smtClean="0"/>
+              <a:rPr lang="en-US"/>
               <a:t>Fourth level</a:t>
             </a:r>
           </a:p>
           <a:p>
             <a:pPr lvl="4"/>
             <a:r>
-              <a:rPr lang="en-US" smtClean="0"/>
+              <a:rPr lang="en-US"/>
               <a:t>Fifth level</a:t>
             </a:r>
-            <a:endParaRPr lang="en-US"/>
           </a:p>
         </p:txBody>
       </p:sp>
@@ -2562,38 +2346,37 @@
           <a:p>
             <a:pPr lvl="0"/>
             <a:r>
-              <a:rPr lang="en-US" smtClean="0"/>
+              <a:rPr lang="en-US"/>
               <a:t>Click to edit Master text styles</a:t>
             </a:r>
           </a:p>
           <a:p>
             <a:pPr lvl="1"/>
             <a:r>
-              <a:rPr lang="en-US" smtClean="0"/>
+              <a:rPr lang="en-US"/>
               <a:t>Second level</a:t>
             </a:r>
           </a:p>
           <a:p>
             <a:pPr lvl="2"/>
             <a:r>
-              <a:rPr lang="en-US" smtClean="0"/>
+              <a:rPr lang="en-US"/>
               <a:t>Third level</a:t>
             </a:r>
           </a:p>
           <a:p>
             <a:pPr lvl="3"/>
             <a:r>
-              <a:rPr lang="en-US" smtClean="0"/>
+              <a:rPr lang="en-US"/>
               <a:t>Fourth level</a:t>
             </a:r>
           </a:p>
           <a:p>
             <a:pPr lvl="4"/>
             <a:r>
-              <a:rPr lang="en-US" smtClean="0"/>
+              <a:rPr lang="en-US"/>
               <a:t>Fifth level</a:t>
             </a:r>
-            <a:endParaRPr lang="en-US"/>
           </a:p>
         </p:txBody>
       </p:sp>
@@ -2614,7 +2397,7 @@
           <a:p>
             <a:fld id="{5BCAD085-E8A6-8845-BD4E-CB4CCA059FC4}" type="datetimeFigureOut">
               <a:rPr lang="en-US" smtClean="0"/>
-              <a:t>1/27/13</a:t>
+              <a:t>9/1/2026</a:t>
             </a:fld>
             <a:endParaRPr lang="en-US"/>
           </a:p>
@@ -2712,10 +2495,9 @@
           </a:lstStyle>
           <a:p>
             <a:r>
-              <a:rPr lang="en-US" smtClean="0"/>
+              <a:rPr lang="en-US"/>
               <a:t>Click to edit Master title style</a:t>
             </a:r>
-            <a:endParaRPr lang="en-US"/>
           </a:p>
         </p:txBody>
       </p:sp>
@@ -2778,7 +2560,7 @@
           <a:p>
             <a:pPr lvl="0"/>
             <a:r>
-              <a:rPr lang="en-US" smtClean="0"/>
+              <a:rPr lang="en-US"/>
               <a:t>Click to edit Master text styles</a:t>
             </a:r>
           </a:p>
@@ -2834,38 +2616,37 @@
           <a:p>
             <a:pPr lvl="0"/>
             <a:r>
-              <a:rPr lang="en-US" smtClean="0"/>
+              <a:rPr lang="en-US"/>
               <a:t>Click to edit Master text styles</a:t>
             </a:r>
           </a:p>
           <a:p>
             <a:pPr lvl="1"/>
             <a:r>
-              <a:rPr lang="en-US" smtClean="0"/>
+              <a:rPr lang="en-US"/>
               <a:t>Second level</a:t>
             </a:r>
           </a:p>
           <a:p>
             <a:pPr lvl="2"/>
             <a:r>
-              <a:rPr lang="en-US" smtClean="0"/>
+              <a:rPr lang="en-US"/>
               <a:t>Third level</a:t>
             </a:r>
           </a:p>
           <a:p>
             <a:pPr lvl="3"/>
             <a:r>
-              <a:rPr lang="en-US" smtClean="0"/>
+              <a:rPr lang="en-US"/>
               <a:t>Fourth level</a:t>
             </a:r>
           </a:p>
           <a:p>
             <a:pPr lvl="4"/>
             <a:r>
-              <a:rPr lang="en-US" smtClean="0"/>
+              <a:rPr lang="en-US"/>
               <a:t>Fifth level</a:t>
             </a:r>
-            <a:endParaRPr lang="en-US"/>
           </a:p>
         </p:txBody>
       </p:sp>
@@ -2928,7 +2709,7 @@
           <a:p>
             <a:pPr lvl="0"/>
             <a:r>
-              <a:rPr lang="en-US" smtClean="0"/>
+              <a:rPr lang="en-US"/>
               <a:t>Click to edit Master text styles</a:t>
             </a:r>
           </a:p>
@@ -2984,38 +2765,37 @@
           <a:p>
             <a:pPr lvl="0"/>
             <a:r>
-              <a:rPr lang="en-US" smtClean="0"/>
+              <a:rPr lang="en-US"/>
               <a:t>Click to edit Master text styles</a:t>
             </a:r>
           </a:p>
           <a:p>
             <a:pPr lvl="1"/>
             <a:r>
-              <a:rPr lang="en-US" smtClean="0"/>
+              <a:rPr lang="en-US"/>
               <a:t>Second level</a:t>
             </a:r>
           </a:p>
           <a:p>
             <a:pPr lvl="2"/>
             <a:r>
-              <a:rPr lang="en-US" smtClean="0"/>
+              <a:rPr lang="en-US"/>
               <a:t>Third level</a:t>
             </a:r>
           </a:p>
           <a:p>
             <a:pPr lvl="3"/>
             <a:r>
-              <a:rPr lang="en-US" smtClean="0"/>
+              <a:rPr lang="en-US"/>
               <a:t>Fourth level</a:t>
             </a:r>
           </a:p>
           <a:p>
             <a:pPr lvl="4"/>
             <a:r>
-              <a:rPr lang="en-US" smtClean="0"/>
+              <a:rPr lang="en-US"/>
               <a:t>Fifth level</a:t>
             </a:r>
-            <a:endParaRPr lang="en-US"/>
           </a:p>
         </p:txBody>
       </p:sp>
@@ -3036,7 +2816,7 @@
           <a:p>
             <a:fld id="{5BCAD085-E8A6-8845-BD4E-CB4CCA059FC4}" type="datetimeFigureOut">
               <a:rPr lang="en-US" smtClean="0"/>
-              <a:t>1/27/13</a:t>
+              <a:t>9/1/2026</a:t>
             </a:fld>
             <a:endParaRPr lang="en-US"/>
           </a:p>
@@ -3130,10 +2910,9 @@
           <a:lstStyle/>
           <a:p>
             <a:r>
-              <a:rPr lang="en-US" smtClean="0"/>
+              <a:rPr lang="en-US"/>
               <a:t>Click to edit Master title style</a:t>
             </a:r>
-            <a:endParaRPr lang="en-US"/>
           </a:p>
         </p:txBody>
       </p:sp>
@@ -3154,7 +2933,7 @@
           <a:p>
             <a:fld id="{5BCAD085-E8A6-8845-BD4E-CB4CCA059FC4}" type="datetimeFigureOut">
               <a:rPr lang="en-US" smtClean="0"/>
-              <a:t>1/27/13</a:t>
+              <a:t>9/1/2026</a:t>
             </a:fld>
             <a:endParaRPr lang="en-US"/>
           </a:p>
@@ -3249,7 +3028,7 @@
           <a:p>
             <a:fld id="{5BCAD085-E8A6-8845-BD4E-CB4CCA059FC4}" type="datetimeFigureOut">
               <a:rPr lang="en-US" smtClean="0"/>
-              <a:t>1/27/13</a:t>
+              <a:t>9/1/2026</a:t>
             </a:fld>
             <a:endParaRPr lang="en-US"/>
           </a:p>
@@ -3352,10 +3131,9 @@
           </a:lstStyle>
           <a:p>
             <a:r>
-              <a:rPr lang="en-US" smtClean="0"/>
+              <a:rPr lang="en-US"/>
               <a:t>Click to edit Master title style</a:t>
             </a:r>
-            <a:endParaRPr lang="en-US"/>
           </a:p>
         </p:txBody>
       </p:sp>
@@ -3409,38 +3187,37 @@
           <a:p>
             <a:pPr lvl="0"/>
             <a:r>
-              <a:rPr lang="en-US" smtClean="0"/>
+              <a:rPr lang="en-US"/>
               <a:t>Click to edit Master text styles</a:t>
             </a:r>
           </a:p>
           <a:p>
             <a:pPr lvl="1"/>
             <a:r>
-              <a:rPr lang="en-US" smtClean="0"/>
+              <a:rPr lang="en-US"/>
               <a:t>Second level</a:t>
             </a:r>
           </a:p>
           <a:p>
             <a:pPr lvl="2"/>
             <a:r>
-              <a:rPr lang="en-US" smtClean="0"/>
+              <a:rPr lang="en-US"/>
               <a:t>Third level</a:t>
             </a:r>
           </a:p>
           <a:p>
             <a:pPr lvl="3"/>
             <a:r>
-              <a:rPr lang="en-US" smtClean="0"/>
+              <a:rPr lang="en-US"/>
               <a:t>Fourth level</a:t>
             </a:r>
           </a:p>
           <a:p>
             <a:pPr lvl="4"/>
             <a:r>
-              <a:rPr lang="en-US" smtClean="0"/>
+              <a:rPr lang="en-US"/>
               <a:t>Fifth level</a:t>
             </a:r>
-            <a:endParaRPr lang="en-US"/>
           </a:p>
         </p:txBody>
       </p:sp>
@@ -3503,7 +3280,7 @@
           <a:p>
             <a:pPr lvl="0"/>
             <a:r>
-              <a:rPr lang="en-US" smtClean="0"/>
+              <a:rPr lang="en-US"/>
               <a:t>Click to edit Master text styles</a:t>
             </a:r>
           </a:p>
@@ -3526,7 +3303,7 @@
           <a:p>
             <a:fld id="{5BCAD085-E8A6-8845-BD4E-CB4CCA059FC4}" type="datetimeFigureOut">
               <a:rPr lang="en-US" smtClean="0"/>
-              <a:t>1/27/13</a:t>
+              <a:t>9/1/2026</a:t>
             </a:fld>
             <a:endParaRPr lang="en-US"/>
           </a:p>
@@ -3629,10 +3406,9 @@
           </a:lstStyle>
           <a:p>
             <a:r>
-              <a:rPr lang="en-US" smtClean="0"/>
+              <a:rPr lang="en-US"/>
               <a:t>Click to edit Master title style</a:t>
             </a:r>
-            <a:endParaRPr lang="en-US"/>
           </a:p>
         </p:txBody>
       </p:sp>
@@ -3756,7 +3532,7 @@
           <a:p>
             <a:pPr lvl="0"/>
             <a:r>
-              <a:rPr lang="en-US" smtClean="0"/>
+              <a:rPr lang="en-US"/>
               <a:t>Click to edit Master text styles</a:t>
             </a:r>
           </a:p>
@@ -3779,7 +3555,7 @@
           <a:p>
             <a:fld id="{5BCAD085-E8A6-8845-BD4E-CB4CCA059FC4}" type="datetimeFigureOut">
               <a:rPr lang="en-US" smtClean="0"/>
-              <a:t>1/27/13</a:t>
+              <a:t>9/1/2026</a:t>
             </a:fld>
             <a:endParaRPr lang="en-US"/>
           </a:p>
@@ -3888,10 +3664,9 @@
           <a:lstStyle/>
           <a:p>
             <a:r>
-              <a:rPr lang="en-US" smtClean="0"/>
+              <a:rPr lang="en-US"/>
               <a:t>Click to edit Master title style</a:t>
             </a:r>
-            <a:endParaRPr lang="en-US"/>
           </a:p>
         </p:txBody>
       </p:sp>
@@ -3922,38 +3697,37 @@
           <a:p>
             <a:pPr lvl="0"/>
             <a:r>
-              <a:rPr lang="en-US" smtClean="0"/>
+              <a:rPr lang="en-US"/>
               <a:t>Click to edit Master text styles</a:t>
             </a:r>
           </a:p>
           <a:p>
             <a:pPr lvl="1"/>
             <a:r>
-              <a:rPr lang="en-US" smtClean="0"/>
+              <a:rPr lang="en-US"/>
               <a:t>Second level</a:t>
             </a:r>
           </a:p>
           <a:p>
             <a:pPr lvl="2"/>
             <a:r>
-              <a:rPr lang="en-US" smtClean="0"/>
+              <a:rPr lang="en-US"/>
               <a:t>Third level</a:t>
             </a:r>
           </a:p>
           <a:p>
             <a:pPr lvl="3"/>
             <a:r>
-              <a:rPr lang="en-US" smtClean="0"/>
+              <a:rPr lang="en-US"/>
               <a:t>Fourth level</a:t>
             </a:r>
           </a:p>
           <a:p>
             <a:pPr lvl="4"/>
             <a:r>
-              <a:rPr lang="en-US" smtClean="0"/>
+              <a:rPr lang="en-US"/>
               <a:t>Fifth level</a:t>
             </a:r>
-            <a:endParaRPr lang="en-US"/>
           </a:p>
         </p:txBody>
       </p:sp>
@@ -3992,7 +3766,7 @@
           <a:p>
             <a:fld id="{5BCAD085-E8A6-8845-BD4E-CB4CCA059FC4}" type="datetimeFigureOut">
               <a:rPr lang="en-US" smtClean="0"/>
-              <a:t>1/27/13</a:t>
+              <a:t>9/1/2026</a:t>
             </a:fld>
             <a:endParaRPr lang="en-US"/>
           </a:p>
@@ -4351,7 +4125,7 @@
 </file>
 
 <file path=ppt/slides/slide1.xml><?xml version="1.0" encoding="utf-8"?>
-<p:sld xmlns:a="http://schemas.openxmlformats.org/drawingml/2006/main" xmlns:p="http://schemas.openxmlformats.org/presentationml/2006/main" xmlns:r="http://schemas.openxmlformats.org/officeDocument/2006/relationships">
+<p:sld xmlns:a="http://schemas.openxmlformats.org/drawingml/2006/main" xmlns:r="http://schemas.openxmlformats.org/officeDocument/2006/relationships" xmlns:p="http://schemas.openxmlformats.org/presentationml/2006/main">
   <p:cSld>
     <p:spTree>
       <p:nvGrpSpPr>
@@ -4359,7 +4133,14 @@
         <p:cNvGrpSpPr/>
         <p:nvPr/>
       </p:nvGrpSpPr>
-      <p:grpSpPr/>
+      <p:grpSpPr>
+        <a:xfrm>
+          <a:off x="0" y="0"/>
+          <a:ext cx="0" cy="0"/>
+          <a:chOff x="0" y="0"/>
+          <a:chExt cx="0" cy="0"/>
+        </a:xfrm>
+      </p:grpSpPr>
       <p:sp>
         <p:nvSpPr>
           <p:cNvPr id="2" name="Rectangle 1"/>
@@ -4400,6 +4181,7 @@
           <a:lstStyle/>
           <a:p>
             <a:pPr algn="ctr"/>
+            <a:endParaRPr/>
           </a:p>
         </p:txBody>
       </p:sp>
@@ -4420,7 +4202,7 @@
           <a:noFill/>
         </p:spPr>
         <p:txBody>
-          <a:bodyPr wrap="square" anchor="t" lIns="0" rIns="0" tIns="0" bIns="0">
+          <a:bodyPr wrap="square" lIns="0" tIns="0" rIns="0" bIns="0" anchor="t">
             <a:spAutoFit/>
           </a:bodyPr>
           <a:lstStyle/>
@@ -4459,7 +4241,7 @@
           <a:noFill/>
         </p:spPr>
         <p:txBody>
-          <a:bodyPr wrap="square" anchor="t" lIns="0" rIns="0" tIns="0" bIns="0">
+          <a:bodyPr wrap="square" lIns="0" tIns="0" rIns="0" bIns="0" anchor="t">
             <a:spAutoFit/>
           </a:bodyPr>
           <a:lstStyle/>
@@ -4498,7 +4280,7 @@
           <a:noFill/>
         </p:spPr>
         <p:txBody>
-          <a:bodyPr wrap="square" anchor="t" lIns="0" rIns="0" tIns="0" bIns="0">
+          <a:bodyPr wrap="square" lIns="0" tIns="0" rIns="0" bIns="0" anchor="t">
             <a:spAutoFit/>
           </a:bodyPr>
           <a:lstStyle/>
@@ -4560,6 +4342,7 @@
           <a:lstStyle/>
           <a:p>
             <a:pPr algn="ctr"/>
+            <a:endParaRPr/>
           </a:p>
         </p:txBody>
       </p:sp>
@@ -4580,7 +4363,7 @@
           <a:noFill/>
         </p:spPr>
         <p:txBody>
-          <a:bodyPr wrap="square" anchor="t" lIns="0" rIns="0" tIns="0" bIns="0">
+          <a:bodyPr wrap="square" lIns="0" tIns="0" rIns="0" bIns="0" anchor="t">
             <a:spAutoFit/>
           </a:bodyPr>
           <a:lstStyle/>
@@ -4619,7 +4402,7 @@
           <a:noFill/>
         </p:spPr>
         <p:txBody>
-          <a:bodyPr wrap="square" anchor="t" lIns="0" rIns="0" tIns="0" bIns="0">
+          <a:bodyPr wrap="square" lIns="0" tIns="0" rIns="0" bIns="0" anchor="t">
             <a:spAutoFit/>
           </a:bodyPr>
           <a:lstStyle/>
@@ -4658,7 +4441,7 @@
           <a:noFill/>
         </p:spPr>
         <p:txBody>
-          <a:bodyPr wrap="square" anchor="t" lIns="0" rIns="0" tIns="0" bIns="0">
+          <a:bodyPr wrap="square" lIns="0" tIns="0" rIns="0" bIns="0" anchor="t">
             <a:spAutoFit/>
           </a:bodyPr>
           <a:lstStyle/>
@@ -4689,7 +4472,7 @@
 </file>
 
 <file path=ppt/slides/slide10.xml><?xml version="1.0" encoding="utf-8"?>
-<p:sld xmlns:a="http://schemas.openxmlformats.org/drawingml/2006/main" xmlns:p="http://schemas.openxmlformats.org/presentationml/2006/main" xmlns:r="http://schemas.openxmlformats.org/officeDocument/2006/relationships">
+<p:sld xmlns:a="http://schemas.openxmlformats.org/drawingml/2006/main" xmlns:r="http://schemas.openxmlformats.org/officeDocument/2006/relationships" xmlns:p="http://schemas.openxmlformats.org/presentationml/2006/main">
   <p:cSld>
     <p:spTree>
       <p:nvGrpSpPr>
@@ -4697,7 +4480,14 @@
         <p:cNvGrpSpPr/>
         <p:nvPr/>
       </p:nvGrpSpPr>
-      <p:grpSpPr/>
+      <p:grpSpPr>
+        <a:xfrm>
+          <a:off x="0" y="0"/>
+          <a:ext cx="0" cy="0"/>
+          <a:chOff x="0" y="0"/>
+          <a:chExt cx="0" cy="0"/>
+        </a:xfrm>
+      </p:grpSpPr>
       <p:sp>
         <p:nvSpPr>
           <p:cNvPr id="2" name="Rectangle 1"/>
@@ -4738,6 +4528,7 @@
           <a:lstStyle/>
           <a:p>
             <a:pPr algn="ctr"/>
+            <a:endParaRPr/>
           </a:p>
         </p:txBody>
       </p:sp>
@@ -4758,7 +4549,7 @@
           <a:noFill/>
         </p:spPr>
         <p:txBody>
-          <a:bodyPr wrap="square" anchor="t" lIns="0" rIns="0" tIns="0" bIns="0">
+          <a:bodyPr wrap="square" lIns="0" tIns="0" rIns="0" bIns="0" anchor="t">
             <a:spAutoFit/>
           </a:bodyPr>
           <a:lstStyle/>
@@ -4820,6 +4611,7 @@
           <a:lstStyle/>
           <a:p>
             <a:pPr algn="ctr"/>
+            <a:endParaRPr/>
           </a:p>
         </p:txBody>
       </p:sp>
@@ -4840,7 +4632,7 @@
           <a:noFill/>
         </p:spPr>
         <p:txBody>
-          <a:bodyPr wrap="square" anchor="t" lIns="0" rIns="0" tIns="0" bIns="0">
+          <a:bodyPr wrap="square" lIns="0" tIns="0" rIns="0" bIns="0" anchor="t">
             <a:spAutoFit/>
           </a:bodyPr>
           <a:lstStyle/>
@@ -4904,6 +4696,7 @@
           <a:lstStyle/>
           <a:p>
             <a:pPr algn="ctr"/>
+            <a:endParaRPr/>
           </a:p>
         </p:txBody>
       </p:sp>
@@ -4924,7 +4717,7 @@
           <a:noFill/>
         </p:spPr>
         <p:txBody>
-          <a:bodyPr wrap="square" anchor="t" lIns="0" rIns="0" tIns="0" bIns="0">
+          <a:bodyPr wrap="square" lIns="0" tIns="0" rIns="0" bIns="0" anchor="t">
             <a:spAutoFit/>
           </a:bodyPr>
           <a:lstStyle/>
@@ -4963,7 +4756,7 @@
           <a:noFill/>
         </p:spPr>
         <p:txBody>
-          <a:bodyPr wrap="square" anchor="t" lIns="0" rIns="0" tIns="0" bIns="0">
+          <a:bodyPr wrap="square" lIns="0" tIns="0" rIns="0" bIns="0" anchor="t">
             <a:spAutoFit/>
           </a:bodyPr>
           <a:lstStyle/>
@@ -5018,7 +4811,7 @@
           <a:noFill/>
         </p:spPr>
         <p:txBody>
-          <a:bodyPr wrap="square" anchor="t" lIns="0" rIns="0" tIns="0" bIns="0">
+          <a:bodyPr wrap="square" lIns="0" tIns="0" rIns="0" bIns="0" anchor="t">
             <a:spAutoFit/>
           </a:bodyPr>
           <a:lstStyle/>
@@ -5082,6 +4875,7 @@
           <a:lstStyle/>
           <a:p>
             <a:pPr algn="ctr"/>
+            <a:endParaRPr/>
           </a:p>
         </p:txBody>
       </p:sp>
@@ -5102,7 +4896,7 @@
           <a:noFill/>
         </p:spPr>
         <p:txBody>
-          <a:bodyPr wrap="square" anchor="t" lIns="0" rIns="0" tIns="0" bIns="0">
+          <a:bodyPr wrap="square" lIns="0" tIns="0" rIns="0" bIns="0" anchor="t">
             <a:spAutoFit/>
           </a:bodyPr>
           <a:lstStyle/>
@@ -5142,7 +4936,7 @@
           <a:noFill/>
         </p:spPr>
         <p:txBody>
-          <a:bodyPr wrap="square" anchor="t" lIns="0" rIns="0" tIns="0" bIns="0">
+          <a:bodyPr wrap="square" lIns="0" tIns="0" rIns="0" bIns="0" anchor="t">
             <a:spAutoFit/>
           </a:bodyPr>
           <a:lstStyle/>
@@ -5205,7 +4999,7 @@
         <p:spPr>
           <a:xfrm>
             <a:off x="566928" y="4069080"/>
-            <a:ext cx="54864" cy="675671"/>
+            <a:ext cx="54864" cy="509693"/>
           </a:xfrm>
           <a:prstGeom prst="rect">
             <a:avLst/>
@@ -5236,6 +5030,7 @@
           <a:lstStyle/>
           <a:p>
             <a:pPr algn="ctr"/>
+            <a:endParaRPr/>
           </a:p>
         </p:txBody>
       </p:sp>
@@ -5256,7 +5051,7 @@
           <a:noFill/>
         </p:spPr>
         <p:txBody>
-          <a:bodyPr wrap="square" anchor="t" lIns="0" rIns="0" tIns="0" bIns="0">
+          <a:bodyPr wrap="square" lIns="0" tIns="0" rIns="0" bIns="0" anchor="t">
             <a:spAutoFit/>
           </a:bodyPr>
           <a:lstStyle/>
@@ -5287,7 +5082,7 @@
 </file>
 
 <file path=ppt/slides/slide11.xml><?xml version="1.0" encoding="utf-8"?>
-<p:sld xmlns:a="http://schemas.openxmlformats.org/drawingml/2006/main" xmlns:p="http://schemas.openxmlformats.org/presentationml/2006/main" xmlns:r="http://schemas.openxmlformats.org/officeDocument/2006/relationships">
+<p:sld xmlns:a="http://schemas.openxmlformats.org/drawingml/2006/main" xmlns:r="http://schemas.openxmlformats.org/officeDocument/2006/relationships" xmlns:p="http://schemas.openxmlformats.org/presentationml/2006/main">
   <p:cSld>
     <p:spTree>
       <p:nvGrpSpPr>
@@ -5295,7 +5090,14 @@
         <p:cNvGrpSpPr/>
         <p:nvPr/>
       </p:nvGrpSpPr>
-      <p:grpSpPr/>
+      <p:grpSpPr>
+        <a:xfrm>
+          <a:off x="0" y="0"/>
+          <a:ext cx="0" cy="0"/>
+          <a:chOff x="0" y="0"/>
+          <a:chExt cx="0" cy="0"/>
+        </a:xfrm>
+      </p:grpSpPr>
       <p:sp>
         <p:nvSpPr>
           <p:cNvPr id="2" name="Rectangle 1"/>
@@ -5304,7 +5106,7 @@
         </p:nvSpPr>
         <p:spPr>
           <a:xfrm>
-            <a:off x="0" y="0"/>
+            <a:off x="0" y="-11430"/>
             <a:ext cx="9144000" cy="5143500"/>
           </a:xfrm>
           <a:prstGeom prst="rect">
@@ -5336,6 +5138,7 @@
           <a:lstStyle/>
           <a:p>
             <a:pPr algn="ctr"/>
+            <a:endParaRPr/>
           </a:p>
         </p:txBody>
       </p:sp>
@@ -5356,7 +5159,7 @@
           <a:noFill/>
         </p:spPr>
         <p:txBody>
-          <a:bodyPr wrap="square" anchor="t" lIns="0" rIns="0" tIns="0" bIns="0">
+          <a:bodyPr wrap="square" lIns="0" tIns="0" rIns="0" bIns="0" anchor="t">
             <a:spAutoFit/>
           </a:bodyPr>
           <a:lstStyle/>
@@ -5418,6 +5221,7 @@
           <a:lstStyle/>
           <a:p>
             <a:pPr algn="ctr"/>
+            <a:endParaRPr/>
           </a:p>
         </p:txBody>
       </p:sp>
@@ -5438,7 +5242,7 @@
           <a:noFill/>
         </p:spPr>
         <p:txBody>
-          <a:bodyPr wrap="square" anchor="t" lIns="0" rIns="0" tIns="0" bIns="0">
+          <a:bodyPr wrap="square" lIns="0" tIns="0" rIns="0" bIns="0" anchor="t">
             <a:spAutoFit/>
           </a:bodyPr>
           <a:lstStyle/>
@@ -5502,6 +5306,7 @@
           <a:lstStyle/>
           <a:p>
             <a:pPr algn="ctr"/>
+            <a:endParaRPr/>
           </a:p>
         </p:txBody>
       </p:sp>
@@ -5545,6 +5350,7 @@
           <a:lstStyle/>
           <a:p>
             <a:pPr algn="ctr"/>
+            <a:endParaRPr/>
           </a:p>
         </p:txBody>
       </p:sp>
@@ -5565,7 +5371,7 @@
           <a:noFill/>
         </p:spPr>
         <p:txBody>
-          <a:bodyPr wrap="square" anchor="t" lIns="0" rIns="0" tIns="0" bIns="0">
+          <a:bodyPr wrap="square" lIns="0" tIns="0" rIns="0" bIns="0" anchor="t">
             <a:spAutoFit/>
           </a:bodyPr>
           <a:lstStyle/>
@@ -5604,7 +5410,7 @@
           <a:noFill/>
         </p:spPr>
         <p:txBody>
-          <a:bodyPr wrap="square" anchor="t" lIns="0" rIns="0" tIns="0" bIns="0">
+          <a:bodyPr wrap="square" lIns="0" tIns="0" rIns="0" bIns="0" anchor="t">
             <a:spAutoFit/>
           </a:bodyPr>
           <a:lstStyle/>
@@ -5668,6 +5474,7 @@
           <a:lstStyle/>
           <a:p>
             <a:pPr algn="ctr"/>
+            <a:endParaRPr/>
           </a:p>
         </p:txBody>
       </p:sp>
@@ -5711,6 +5518,7 @@
           <a:lstStyle/>
           <a:p>
             <a:pPr algn="ctr"/>
+            <a:endParaRPr/>
           </a:p>
         </p:txBody>
       </p:sp>
@@ -5731,7 +5539,7 @@
           <a:noFill/>
         </p:spPr>
         <p:txBody>
-          <a:bodyPr wrap="square" anchor="t" lIns="0" rIns="0" tIns="0" bIns="0">
+          <a:bodyPr wrap="square" lIns="0" tIns="0" rIns="0" bIns="0" anchor="t">
             <a:spAutoFit/>
           </a:bodyPr>
           <a:lstStyle/>
@@ -5770,7 +5578,7 @@
           <a:noFill/>
         </p:spPr>
         <p:txBody>
-          <a:bodyPr wrap="square" anchor="t" lIns="0" rIns="0" tIns="0" bIns="0">
+          <a:bodyPr wrap="square" lIns="0" tIns="0" rIns="0" bIns="0" anchor="t">
             <a:spAutoFit/>
           </a:bodyPr>
           <a:lstStyle/>
@@ -5834,6 +5642,7 @@
           <a:lstStyle/>
           <a:p>
             <a:pPr algn="ctr"/>
+            <a:endParaRPr/>
           </a:p>
         </p:txBody>
       </p:sp>
@@ -5877,6 +5686,7 @@
           <a:lstStyle/>
           <a:p>
             <a:pPr algn="ctr"/>
+            <a:endParaRPr/>
           </a:p>
         </p:txBody>
       </p:sp>
@@ -5897,7 +5707,7 @@
           <a:noFill/>
         </p:spPr>
         <p:txBody>
-          <a:bodyPr wrap="square" anchor="t" lIns="0" rIns="0" tIns="0" bIns="0">
+          <a:bodyPr wrap="square" lIns="0" tIns="0" rIns="0" bIns="0" anchor="t">
             <a:spAutoFit/>
           </a:bodyPr>
           <a:lstStyle/>
@@ -5936,7 +5746,7 @@
           <a:noFill/>
         </p:spPr>
         <p:txBody>
-          <a:bodyPr wrap="square" anchor="t" lIns="0" rIns="0" tIns="0" bIns="0">
+          <a:bodyPr wrap="square" lIns="0" tIns="0" rIns="0" bIns="0" anchor="t">
             <a:spAutoFit/>
           </a:bodyPr>
           <a:lstStyle/>
@@ -6000,6 +5810,7 @@
           <a:lstStyle/>
           <a:p>
             <a:pPr algn="ctr"/>
+            <a:endParaRPr/>
           </a:p>
         </p:txBody>
       </p:sp>
@@ -6043,6 +5854,7 @@
           <a:lstStyle/>
           <a:p>
             <a:pPr algn="ctr"/>
+            <a:endParaRPr/>
           </a:p>
         </p:txBody>
       </p:sp>
@@ -6063,7 +5875,7 @@
           <a:noFill/>
         </p:spPr>
         <p:txBody>
-          <a:bodyPr wrap="square" anchor="t" lIns="0" rIns="0" tIns="0" bIns="0">
+          <a:bodyPr wrap="square" lIns="0" tIns="0" rIns="0" bIns="0" anchor="t">
             <a:spAutoFit/>
           </a:bodyPr>
           <a:lstStyle/>
@@ -6102,7 +5914,7 @@
           <a:noFill/>
         </p:spPr>
         <p:txBody>
-          <a:bodyPr wrap="square" anchor="t" lIns="0" rIns="0" tIns="0" bIns="0">
+          <a:bodyPr wrap="square" lIns="0" tIns="0" rIns="0" bIns="0" anchor="t">
             <a:spAutoFit/>
           </a:bodyPr>
           <a:lstStyle/>
@@ -6133,7 +5945,7 @@
         <p:spPr>
           <a:xfrm>
             <a:off x="566928" y="4224528"/>
-            <a:ext cx="54864" cy="584390"/>
+            <a:ext cx="54864" cy="464058"/>
           </a:xfrm>
           <a:prstGeom prst="rect">
             <a:avLst/>
@@ -6164,6 +5976,7 @@
           <a:lstStyle/>
           <a:p>
             <a:pPr algn="ctr"/>
+            <a:endParaRPr/>
           </a:p>
         </p:txBody>
       </p:sp>
@@ -6184,7 +5997,7 @@
           <a:noFill/>
         </p:spPr>
         <p:txBody>
-          <a:bodyPr wrap="square" anchor="t" lIns="0" rIns="0" tIns="0" bIns="0">
+          <a:bodyPr wrap="square" lIns="0" tIns="0" rIns="0" bIns="0" anchor="t">
             <a:spAutoFit/>
           </a:bodyPr>
           <a:lstStyle/>
@@ -6215,7 +6028,7 @@
 </file>
 
 <file path=ppt/slides/slide12.xml><?xml version="1.0" encoding="utf-8"?>
-<p:sld xmlns:a="http://schemas.openxmlformats.org/drawingml/2006/main" xmlns:p="http://schemas.openxmlformats.org/presentationml/2006/main" xmlns:r="http://schemas.openxmlformats.org/officeDocument/2006/relationships">
+<p:sld xmlns:a="http://schemas.openxmlformats.org/drawingml/2006/main" xmlns:r="http://schemas.openxmlformats.org/officeDocument/2006/relationships" xmlns:p="http://schemas.openxmlformats.org/presentationml/2006/main">
   <p:cSld>
     <p:spTree>
       <p:nvGrpSpPr>
@@ -6223,7 +6036,14 @@
         <p:cNvGrpSpPr/>
         <p:nvPr/>
       </p:nvGrpSpPr>
-      <p:grpSpPr/>
+      <p:grpSpPr>
+        <a:xfrm>
+          <a:off x="0" y="0"/>
+          <a:ext cx="0" cy="0"/>
+          <a:chOff x="0" y="0"/>
+          <a:chExt cx="0" cy="0"/>
+        </a:xfrm>
+      </p:grpSpPr>
       <p:sp>
         <p:nvSpPr>
           <p:cNvPr id="2" name="Rectangle 1"/>
@@ -6264,6 +6084,7 @@
           <a:lstStyle/>
           <a:p>
             <a:pPr algn="ctr"/>
+            <a:endParaRPr/>
           </a:p>
         </p:txBody>
       </p:sp>
@@ -6284,7 +6105,7 @@
           <a:noFill/>
         </p:spPr>
         <p:txBody>
-          <a:bodyPr wrap="square" anchor="t" lIns="0" rIns="0" tIns="0" bIns="0">
+          <a:bodyPr wrap="square" lIns="0" tIns="0" rIns="0" bIns="0" anchor="t">
             <a:spAutoFit/>
           </a:bodyPr>
           <a:lstStyle/>
@@ -6346,6 +6167,7 @@
           <a:lstStyle/>
           <a:p>
             <a:pPr algn="ctr"/>
+            <a:endParaRPr/>
           </a:p>
         </p:txBody>
       </p:sp>
@@ -6366,7 +6188,7 @@
           <a:noFill/>
         </p:spPr>
         <p:txBody>
-          <a:bodyPr wrap="square" anchor="t" lIns="0" rIns="0" tIns="0" bIns="0">
+          <a:bodyPr wrap="square" lIns="0" tIns="0" rIns="0" bIns="0" anchor="t">
             <a:spAutoFit/>
           </a:bodyPr>
           <a:lstStyle/>
@@ -6405,7 +6227,7 @@
           <a:noFill/>
         </p:spPr>
         <p:txBody>
-          <a:bodyPr wrap="square" anchor="t" lIns="0" rIns="0" tIns="0" bIns="0">
+          <a:bodyPr wrap="square" lIns="0" tIns="0" rIns="0" bIns="0" anchor="t">
             <a:spAutoFit/>
           </a:bodyPr>
           <a:lstStyle/>
@@ -6444,7 +6266,7 @@
           <a:noFill/>
         </p:spPr>
         <p:txBody>
-          <a:bodyPr wrap="square" anchor="t" lIns="0" rIns="0" tIns="0" bIns="0">
+          <a:bodyPr wrap="square" lIns="0" tIns="0" rIns="0" bIns="0" anchor="t">
             <a:spAutoFit/>
           </a:bodyPr>
           <a:lstStyle/>
@@ -6483,7 +6305,7 @@
           <a:noFill/>
         </p:spPr>
         <p:txBody>
-          <a:bodyPr wrap="square" anchor="t" lIns="0" rIns="0" tIns="0" bIns="0">
+          <a:bodyPr wrap="square" lIns="0" tIns="0" rIns="0" bIns="0" anchor="t">
             <a:spAutoFit/>
           </a:bodyPr>
           <a:lstStyle/>
@@ -6547,6 +6369,7 @@
           <a:lstStyle/>
           <a:p>
             <a:pPr algn="ctr"/>
+            <a:endParaRPr/>
           </a:p>
         </p:txBody>
       </p:sp>
@@ -6567,7 +6390,7 @@
           <a:noFill/>
         </p:spPr>
         <p:txBody>
-          <a:bodyPr wrap="square" anchor="t" lIns="0" rIns="0" tIns="0" bIns="0">
+          <a:bodyPr wrap="square" lIns="0" tIns="0" rIns="0" bIns="0" anchor="t">
             <a:spAutoFit/>
           </a:bodyPr>
           <a:lstStyle/>
@@ -6638,7 +6461,7 @@
           <a:noFill/>
         </p:spPr>
         <p:txBody>
-          <a:bodyPr wrap="square" anchor="t" lIns="0" rIns="0" tIns="0" bIns="0">
+          <a:bodyPr wrap="square" lIns="0" tIns="0" rIns="0" bIns="0" anchor="t">
             <a:spAutoFit/>
           </a:bodyPr>
           <a:lstStyle/>
@@ -6669,7 +6492,7 @@
 </file>
 
 <file path=ppt/slides/slide13.xml><?xml version="1.0" encoding="utf-8"?>
-<p:sld xmlns:a="http://schemas.openxmlformats.org/drawingml/2006/main" xmlns:p="http://schemas.openxmlformats.org/presentationml/2006/main" xmlns:r="http://schemas.openxmlformats.org/officeDocument/2006/relationships">
+<p:sld xmlns:a="http://schemas.openxmlformats.org/drawingml/2006/main" xmlns:r="http://schemas.openxmlformats.org/officeDocument/2006/relationships" xmlns:p="http://schemas.openxmlformats.org/presentationml/2006/main">
   <p:cSld>
     <p:spTree>
       <p:nvGrpSpPr>
@@ -6677,7 +6500,14 @@
         <p:cNvGrpSpPr/>
         <p:nvPr/>
       </p:nvGrpSpPr>
-      <p:grpSpPr/>
+      <p:grpSpPr>
+        <a:xfrm>
+          <a:off x="0" y="0"/>
+          <a:ext cx="0" cy="0"/>
+          <a:chOff x="0" y="0"/>
+          <a:chExt cx="0" cy="0"/>
+        </a:xfrm>
+      </p:grpSpPr>
       <p:sp>
         <p:nvSpPr>
           <p:cNvPr id="2" name="Rectangle 1"/>
@@ -6718,6 +6548,7 @@
           <a:lstStyle/>
           <a:p>
             <a:pPr algn="ctr"/>
+            <a:endParaRPr/>
           </a:p>
         </p:txBody>
       </p:sp>
@@ -6738,7 +6569,7 @@
           <a:noFill/>
         </p:spPr>
         <p:txBody>
-          <a:bodyPr wrap="square" anchor="t" lIns="0" rIns="0" tIns="0" bIns="0">
+          <a:bodyPr wrap="square" lIns="0" tIns="0" rIns="0" bIns="0" anchor="t">
             <a:spAutoFit/>
           </a:bodyPr>
           <a:lstStyle/>
@@ -6800,6 +6631,7 @@
           <a:lstStyle/>
           <a:p>
             <a:pPr algn="ctr"/>
+            <a:endParaRPr/>
           </a:p>
         </p:txBody>
       </p:sp>
@@ -6820,7 +6652,7 @@
           <a:noFill/>
         </p:spPr>
         <p:txBody>
-          <a:bodyPr wrap="square" anchor="t" lIns="0" rIns="0" tIns="0" bIns="0">
+          <a:bodyPr wrap="square" lIns="0" tIns="0" rIns="0" bIns="0" anchor="t">
             <a:spAutoFit/>
           </a:bodyPr>
           <a:lstStyle/>
@@ -6859,7 +6691,7 @@
           <a:noFill/>
         </p:spPr>
         <p:txBody>
-          <a:bodyPr wrap="square" anchor="t" lIns="0" rIns="0" tIns="0" bIns="0">
+          <a:bodyPr wrap="square" lIns="0" tIns="0" rIns="0" bIns="0" anchor="t">
             <a:spAutoFit/>
           </a:bodyPr>
           <a:lstStyle/>
@@ -6924,6 +6756,7 @@
           <a:lstStyle/>
           <a:p>
             <a:pPr algn="ctr"/>
+            <a:endParaRPr/>
           </a:p>
         </p:txBody>
       </p:sp>
@@ -6944,7 +6777,7 @@
           <a:noFill/>
         </p:spPr>
         <p:txBody>
-          <a:bodyPr wrap="square" anchor="t" lIns="0" rIns="0" tIns="0" bIns="0">
+          <a:bodyPr wrap="square" lIns="0" tIns="0" rIns="0" bIns="0" anchor="t">
             <a:spAutoFit/>
           </a:bodyPr>
           <a:lstStyle/>
@@ -6983,7 +6816,7 @@
           <a:noFill/>
         </p:spPr>
         <p:txBody>
-          <a:bodyPr wrap="square" anchor="t" lIns="0" rIns="0" tIns="0" bIns="0">
+          <a:bodyPr wrap="square" lIns="0" tIns="0" rIns="0" bIns="0" anchor="t">
             <a:spAutoFit/>
           </a:bodyPr>
           <a:lstStyle/>
@@ -7014,7 +6847,7 @@
 </file>
 
 <file path=ppt/slides/slide2.xml><?xml version="1.0" encoding="utf-8"?>
-<p:sld xmlns:a="http://schemas.openxmlformats.org/drawingml/2006/main" xmlns:p="http://schemas.openxmlformats.org/presentationml/2006/main" xmlns:r="http://schemas.openxmlformats.org/officeDocument/2006/relationships">
+<p:sld xmlns:a="http://schemas.openxmlformats.org/drawingml/2006/main" xmlns:r="http://schemas.openxmlformats.org/officeDocument/2006/relationships" xmlns:p="http://schemas.openxmlformats.org/presentationml/2006/main">
   <p:cSld>
     <p:spTree>
       <p:nvGrpSpPr>
@@ -7022,7 +6855,14 @@
         <p:cNvGrpSpPr/>
         <p:nvPr/>
       </p:nvGrpSpPr>
-      <p:grpSpPr/>
+      <p:grpSpPr>
+        <a:xfrm>
+          <a:off x="0" y="0"/>
+          <a:ext cx="0" cy="0"/>
+          <a:chOff x="0" y="0"/>
+          <a:chExt cx="0" cy="0"/>
+        </a:xfrm>
+      </p:grpSpPr>
       <p:sp>
         <p:nvSpPr>
           <p:cNvPr id="2" name="Rectangle 1"/>
@@ -7063,6 +6903,7 @@
           <a:lstStyle/>
           <a:p>
             <a:pPr algn="ctr"/>
+            <a:endParaRPr/>
           </a:p>
         </p:txBody>
       </p:sp>
@@ -7083,7 +6924,7 @@
           <a:noFill/>
         </p:spPr>
         <p:txBody>
-          <a:bodyPr wrap="square" anchor="t" lIns="0" rIns="0" tIns="0" bIns="0">
+          <a:bodyPr wrap="square" lIns="0" tIns="0" rIns="0" bIns="0" anchor="t">
             <a:spAutoFit/>
           </a:bodyPr>
           <a:lstStyle/>
@@ -7145,6 +6986,7 @@
           <a:lstStyle/>
           <a:p>
             <a:pPr algn="ctr"/>
+            <a:endParaRPr/>
           </a:p>
         </p:txBody>
       </p:sp>
@@ -7165,7 +7007,7 @@
           <a:noFill/>
         </p:spPr>
         <p:txBody>
-          <a:bodyPr wrap="square" anchor="t" lIns="0" rIns="0" tIns="0" bIns="0">
+          <a:bodyPr wrap="square" lIns="0" tIns="0" rIns="0" bIns="0" anchor="t">
             <a:spAutoFit/>
           </a:bodyPr>
           <a:lstStyle/>
@@ -7204,7 +7046,7 @@
           <a:noFill/>
         </p:spPr>
         <p:txBody>
-          <a:bodyPr wrap="square" anchor="t" lIns="0" rIns="0" tIns="0" bIns="0">
+          <a:bodyPr wrap="square" lIns="0" tIns="0" rIns="0" bIns="0" anchor="t">
             <a:spAutoFit/>
           </a:bodyPr>
           <a:lstStyle/>
@@ -7268,6 +7110,7 @@
           <a:lstStyle/>
           <a:p>
             <a:pPr algn="ctr"/>
+            <a:endParaRPr/>
           </a:p>
         </p:txBody>
       </p:sp>
@@ -7288,7 +7131,7 @@
           <a:noFill/>
         </p:spPr>
         <p:txBody>
-          <a:bodyPr wrap="square" anchor="t" lIns="0" rIns="0" tIns="0" bIns="0">
+          <a:bodyPr wrap="square" lIns="0" tIns="0" rIns="0" bIns="0" anchor="t">
             <a:spAutoFit/>
           </a:bodyPr>
           <a:lstStyle/>
@@ -7327,7 +7170,7 @@
           <a:noFill/>
         </p:spPr>
         <p:txBody>
-          <a:bodyPr wrap="square" anchor="t" lIns="0" rIns="0" tIns="0" bIns="0">
+          <a:bodyPr wrap="square" lIns="0" tIns="0" rIns="0" bIns="0" anchor="t">
             <a:spAutoFit/>
           </a:bodyPr>
           <a:lstStyle/>
@@ -7406,7 +7249,7 @@
 </file>
 
 <file path=ppt/slides/slide3.xml><?xml version="1.0" encoding="utf-8"?>
-<p:sld xmlns:a="http://schemas.openxmlformats.org/drawingml/2006/main" xmlns:p="http://schemas.openxmlformats.org/presentationml/2006/main" xmlns:r="http://schemas.openxmlformats.org/officeDocument/2006/relationships">
+<p:sld xmlns:a="http://schemas.openxmlformats.org/drawingml/2006/main" xmlns:r="http://schemas.openxmlformats.org/officeDocument/2006/relationships" xmlns:p="http://schemas.openxmlformats.org/presentationml/2006/main">
   <p:cSld>
     <p:spTree>
       <p:nvGrpSpPr>
@@ -7414,7 +7257,14 @@
         <p:cNvGrpSpPr/>
         <p:nvPr/>
       </p:nvGrpSpPr>
-      <p:grpSpPr/>
+      <p:grpSpPr>
+        <a:xfrm>
+          <a:off x="0" y="0"/>
+          <a:ext cx="0" cy="0"/>
+          <a:chOff x="0" y="0"/>
+          <a:chExt cx="0" cy="0"/>
+        </a:xfrm>
+      </p:grpSpPr>
       <p:sp>
         <p:nvSpPr>
           <p:cNvPr id="2" name="Rectangle 1"/>
@@ -7455,6 +7305,7 @@
           <a:lstStyle/>
           <a:p>
             <a:pPr algn="ctr"/>
+            <a:endParaRPr/>
           </a:p>
         </p:txBody>
       </p:sp>
@@ -7475,7 +7326,7 @@
           <a:noFill/>
         </p:spPr>
         <p:txBody>
-          <a:bodyPr wrap="square" anchor="t" lIns="0" rIns="0" tIns="0" bIns="0">
+          <a:bodyPr wrap="square" lIns="0" tIns="0" rIns="0" bIns="0" anchor="t">
             <a:spAutoFit/>
           </a:bodyPr>
           <a:lstStyle/>
@@ -7537,6 +7388,7 @@
           <a:lstStyle/>
           <a:p>
             <a:pPr algn="ctr"/>
+            <a:endParaRPr/>
           </a:p>
         </p:txBody>
       </p:sp>
@@ -7557,7 +7409,7 @@
           <a:noFill/>
         </p:spPr>
         <p:txBody>
-          <a:bodyPr wrap="square" anchor="t" lIns="0" rIns="0" tIns="0" bIns="0">
+          <a:bodyPr wrap="square" lIns="0" tIns="0" rIns="0" bIns="0" anchor="t">
             <a:spAutoFit/>
           </a:bodyPr>
           <a:lstStyle/>
@@ -7596,7 +7448,7 @@
           <a:noFill/>
         </p:spPr>
         <p:txBody>
-          <a:bodyPr wrap="square" anchor="t" lIns="0" rIns="0" tIns="0" bIns="0">
+          <a:bodyPr wrap="square" lIns="0" tIns="0" rIns="0" bIns="0" anchor="t">
             <a:spAutoFit/>
           </a:bodyPr>
           <a:lstStyle/>
@@ -7660,6 +7512,7 @@
           <a:lstStyle/>
           <a:p>
             <a:pPr algn="ctr"/>
+            <a:endParaRPr/>
           </a:p>
         </p:txBody>
       </p:sp>
@@ -7680,7 +7533,7 @@
           <a:noFill/>
         </p:spPr>
         <p:txBody>
-          <a:bodyPr wrap="square" anchor="t" lIns="0" rIns="0" tIns="0" bIns="0">
+          <a:bodyPr wrap="square" lIns="0" tIns="0" rIns="0" bIns="0" anchor="t">
             <a:spAutoFit/>
           </a:bodyPr>
           <a:lstStyle/>
@@ -7719,7 +7572,7 @@
           <a:noFill/>
         </p:spPr>
         <p:txBody>
-          <a:bodyPr wrap="square" anchor="t" lIns="0" rIns="0" tIns="0" bIns="0">
+          <a:bodyPr wrap="square" lIns="0" tIns="0" rIns="0" bIns="0" anchor="t">
             <a:spAutoFit/>
           </a:bodyPr>
           <a:lstStyle/>
@@ -7758,7 +7611,7 @@
           <a:noFill/>
         </p:spPr>
         <p:txBody>
-          <a:bodyPr wrap="square" anchor="t" lIns="0" rIns="0" tIns="0" bIns="0">
+          <a:bodyPr wrap="square" lIns="0" tIns="0" rIns="0" bIns="0" anchor="t">
             <a:spAutoFit/>
           </a:bodyPr>
           <a:lstStyle/>
@@ -7820,6 +7673,7 @@
           <a:lstStyle/>
           <a:p>
             <a:pPr algn="ctr"/>
+            <a:endParaRPr/>
           </a:p>
         </p:txBody>
       </p:sp>
@@ -7840,7 +7694,7 @@
           <a:noFill/>
         </p:spPr>
         <p:txBody>
-          <a:bodyPr wrap="square" anchor="t" lIns="0" rIns="0" tIns="0" bIns="0">
+          <a:bodyPr wrap="square" lIns="0" tIns="0" rIns="0" bIns="0" anchor="t">
             <a:spAutoFit/>
           </a:bodyPr>
           <a:lstStyle/>
@@ -7902,6 +7756,7 @@
           <a:lstStyle/>
           <a:p>
             <a:pPr algn="ctr"/>
+            <a:endParaRPr/>
           </a:p>
         </p:txBody>
       </p:sp>
@@ -7922,7 +7777,7 @@
           <a:noFill/>
         </p:spPr>
         <p:txBody>
-          <a:bodyPr wrap="square" anchor="t" lIns="0" rIns="0" tIns="0" bIns="0">
+          <a:bodyPr wrap="square" lIns="0" tIns="0" rIns="0" bIns="0" anchor="t">
             <a:spAutoFit/>
           </a:bodyPr>
           <a:lstStyle/>
@@ -7961,7 +7816,7 @@
           <a:noFill/>
         </p:spPr>
         <p:txBody>
-          <a:bodyPr wrap="square" anchor="t" lIns="0" rIns="0" tIns="0" bIns="0">
+          <a:bodyPr wrap="square" lIns="0" tIns="0" rIns="0" bIns="0" anchor="t">
             <a:spAutoFit/>
           </a:bodyPr>
           <a:lstStyle/>
@@ -8023,6 +7878,7 @@
           <a:lstStyle/>
           <a:p>
             <a:pPr algn="ctr"/>
+            <a:endParaRPr/>
           </a:p>
         </p:txBody>
       </p:sp>
@@ -8043,7 +7899,7 @@
           <a:noFill/>
         </p:spPr>
         <p:txBody>
-          <a:bodyPr wrap="square" anchor="t" lIns="0" rIns="0" tIns="0" bIns="0">
+          <a:bodyPr wrap="square" lIns="0" tIns="0" rIns="0" bIns="0" anchor="t">
             <a:spAutoFit/>
           </a:bodyPr>
           <a:lstStyle/>
@@ -8074,7 +7930,7 @@
 </file>
 
 <file path=ppt/slides/slide4.xml><?xml version="1.0" encoding="utf-8"?>
-<p:sld xmlns:a="http://schemas.openxmlformats.org/drawingml/2006/main" xmlns:p="http://schemas.openxmlformats.org/presentationml/2006/main" xmlns:r="http://schemas.openxmlformats.org/officeDocument/2006/relationships">
+<p:sld xmlns:a="http://schemas.openxmlformats.org/drawingml/2006/main" xmlns:r="http://schemas.openxmlformats.org/officeDocument/2006/relationships" xmlns:p="http://schemas.openxmlformats.org/presentationml/2006/main">
   <p:cSld>
     <p:spTree>
       <p:nvGrpSpPr>
@@ -8082,7 +7938,14 @@
         <p:cNvGrpSpPr/>
         <p:nvPr/>
       </p:nvGrpSpPr>
-      <p:grpSpPr/>
+      <p:grpSpPr>
+        <a:xfrm>
+          <a:off x="0" y="0"/>
+          <a:ext cx="0" cy="0"/>
+          <a:chOff x="0" y="0"/>
+          <a:chExt cx="0" cy="0"/>
+        </a:xfrm>
+      </p:grpSpPr>
       <p:sp>
         <p:nvSpPr>
           <p:cNvPr id="2" name="Rectangle 1"/>
@@ -8123,6 +7986,7 @@
           <a:lstStyle/>
           <a:p>
             <a:pPr algn="ctr"/>
+            <a:endParaRPr/>
           </a:p>
         </p:txBody>
       </p:sp>
@@ -8143,7 +8007,7 @@
           <a:noFill/>
         </p:spPr>
         <p:txBody>
-          <a:bodyPr wrap="square" anchor="t" lIns="0" rIns="0" tIns="0" bIns="0">
+          <a:bodyPr wrap="square" lIns="0" tIns="0" rIns="0" bIns="0" anchor="t">
             <a:spAutoFit/>
           </a:bodyPr>
           <a:lstStyle/>
@@ -8205,6 +8069,7 @@
           <a:lstStyle/>
           <a:p>
             <a:pPr algn="ctr"/>
+            <a:endParaRPr/>
           </a:p>
         </p:txBody>
       </p:sp>
@@ -8225,7 +8090,7 @@
           <a:noFill/>
         </p:spPr>
         <p:txBody>
-          <a:bodyPr wrap="square" anchor="t" lIns="0" rIns="0" tIns="0" bIns="0">
+          <a:bodyPr wrap="square" lIns="0" tIns="0" rIns="0" bIns="0" anchor="t">
             <a:spAutoFit/>
           </a:bodyPr>
           <a:lstStyle/>
@@ -8289,6 +8154,7 @@
           <a:lstStyle/>
           <a:p>
             <a:pPr algn="ctr"/>
+            <a:endParaRPr/>
           </a:p>
         </p:txBody>
       </p:sp>
@@ -8309,7 +8175,7 @@
           <a:noFill/>
         </p:spPr>
         <p:txBody>
-          <a:bodyPr wrap="square" anchor="t" lIns="0" rIns="0" tIns="0" bIns="0">
+          <a:bodyPr wrap="square" lIns="0" tIns="0" rIns="0" bIns="0" anchor="t">
             <a:spAutoFit/>
           </a:bodyPr>
           <a:lstStyle/>
@@ -8348,7 +8214,7 @@
           <a:noFill/>
         </p:spPr>
         <p:txBody>
-          <a:bodyPr wrap="square" anchor="t" lIns="0" rIns="0" tIns="0" bIns="0">
+          <a:bodyPr wrap="square" lIns="0" tIns="0" rIns="0" bIns="0" anchor="t">
             <a:spAutoFit/>
           </a:bodyPr>
           <a:lstStyle/>
@@ -8387,7 +8253,7 @@
           <a:noFill/>
         </p:spPr>
         <p:txBody>
-          <a:bodyPr wrap="square" anchor="t" lIns="0" rIns="0" tIns="0" bIns="0">
+          <a:bodyPr wrap="square" lIns="0" tIns="0" rIns="0" bIns="0" anchor="t">
             <a:spAutoFit/>
           </a:bodyPr>
           <a:lstStyle/>
@@ -8467,6 +8333,7 @@
           <a:lstStyle/>
           <a:p>
             <a:pPr algn="ctr"/>
+            <a:endParaRPr/>
           </a:p>
         </p:txBody>
       </p:sp>
@@ -8487,7 +8354,7 @@
           <a:noFill/>
         </p:spPr>
         <p:txBody>
-          <a:bodyPr wrap="square" anchor="t" lIns="0" rIns="0" tIns="0" bIns="0">
+          <a:bodyPr wrap="square" lIns="0" tIns="0" rIns="0" bIns="0" anchor="t">
             <a:spAutoFit/>
           </a:bodyPr>
           <a:lstStyle/>
@@ -8526,7 +8393,7 @@
           <a:noFill/>
         </p:spPr>
         <p:txBody>
-          <a:bodyPr wrap="square" anchor="t" lIns="0" rIns="0" tIns="0" bIns="0">
+          <a:bodyPr wrap="square" lIns="0" tIns="0" rIns="0" bIns="0" anchor="t">
             <a:spAutoFit/>
           </a:bodyPr>
           <a:lstStyle/>
@@ -8565,7 +8432,7 @@
           <a:noFill/>
         </p:spPr>
         <p:txBody>
-          <a:bodyPr wrap="square" anchor="t" lIns="0" rIns="0" tIns="0" bIns="0">
+          <a:bodyPr wrap="square" lIns="0" tIns="0" rIns="0" bIns="0" anchor="t">
             <a:spAutoFit/>
           </a:bodyPr>
           <a:lstStyle/>
@@ -8645,6 +8512,7 @@
           <a:lstStyle/>
           <a:p>
             <a:pPr algn="ctr"/>
+            <a:endParaRPr/>
           </a:p>
         </p:txBody>
       </p:sp>
@@ -8665,7 +8533,7 @@
           <a:noFill/>
         </p:spPr>
         <p:txBody>
-          <a:bodyPr wrap="square" anchor="t" lIns="0" rIns="0" tIns="0" bIns="0">
+          <a:bodyPr wrap="square" lIns="0" tIns="0" rIns="0" bIns="0" anchor="t">
             <a:spAutoFit/>
           </a:bodyPr>
           <a:lstStyle/>
@@ -8704,7 +8572,7 @@
           <a:noFill/>
         </p:spPr>
         <p:txBody>
-          <a:bodyPr wrap="square" anchor="t" lIns="0" rIns="0" tIns="0" bIns="0">
+          <a:bodyPr wrap="square" lIns="0" tIns="0" rIns="0" bIns="0" anchor="t">
             <a:spAutoFit/>
           </a:bodyPr>
           <a:lstStyle/>
@@ -8743,7 +8611,7 @@
           <a:noFill/>
         </p:spPr>
         <p:txBody>
-          <a:bodyPr wrap="square" anchor="t" lIns="0" rIns="0" tIns="0" bIns="0">
+          <a:bodyPr wrap="square" lIns="0" tIns="0" rIns="0" bIns="0" anchor="t">
             <a:spAutoFit/>
           </a:bodyPr>
           <a:lstStyle/>
@@ -8798,7 +8666,7 @@
           <a:noFill/>
         </p:spPr>
         <p:txBody>
-          <a:bodyPr wrap="square" anchor="t" lIns="0" rIns="0" tIns="0" bIns="0">
+          <a:bodyPr wrap="square" lIns="0" tIns="0" rIns="0" bIns="0" anchor="t">
             <a:spAutoFit/>
           </a:bodyPr>
           <a:lstStyle/>
@@ -8829,7 +8697,7 @@
 </file>
 
 <file path=ppt/slides/slide5.xml><?xml version="1.0" encoding="utf-8"?>
-<p:sld xmlns:a="http://schemas.openxmlformats.org/drawingml/2006/main" xmlns:p="http://schemas.openxmlformats.org/presentationml/2006/main" xmlns:r="http://schemas.openxmlformats.org/officeDocument/2006/relationships">
+<p:sld xmlns:a="http://schemas.openxmlformats.org/drawingml/2006/main" xmlns:r="http://schemas.openxmlformats.org/officeDocument/2006/relationships" xmlns:p="http://schemas.openxmlformats.org/presentationml/2006/main">
   <p:cSld>
     <p:spTree>
       <p:nvGrpSpPr>
@@ -8837,7 +8705,14 @@
         <p:cNvGrpSpPr/>
         <p:nvPr/>
       </p:nvGrpSpPr>
-      <p:grpSpPr/>
+      <p:grpSpPr>
+        <a:xfrm>
+          <a:off x="0" y="0"/>
+          <a:ext cx="0" cy="0"/>
+          <a:chOff x="0" y="0"/>
+          <a:chExt cx="0" cy="0"/>
+        </a:xfrm>
+      </p:grpSpPr>
       <p:sp>
         <p:nvSpPr>
           <p:cNvPr id="2" name="Rectangle 1"/>
@@ -8878,6 +8753,7 @@
           <a:lstStyle/>
           <a:p>
             <a:pPr algn="ctr"/>
+            <a:endParaRPr/>
           </a:p>
         </p:txBody>
       </p:sp>
@@ -8898,7 +8774,7 @@
           <a:noFill/>
         </p:spPr>
         <p:txBody>
-          <a:bodyPr wrap="square" anchor="t" lIns="0" rIns="0" tIns="0" bIns="0">
+          <a:bodyPr wrap="square" lIns="0" tIns="0" rIns="0" bIns="0" anchor="t">
             <a:spAutoFit/>
           </a:bodyPr>
           <a:lstStyle/>
@@ -8960,6 +8836,7 @@
           <a:lstStyle/>
           <a:p>
             <a:pPr algn="ctr"/>
+            <a:endParaRPr/>
           </a:p>
         </p:txBody>
       </p:sp>
@@ -8980,7 +8857,7 @@
           <a:noFill/>
         </p:spPr>
         <p:txBody>
-          <a:bodyPr wrap="square" anchor="t" lIns="0" rIns="0" tIns="0" bIns="0">
+          <a:bodyPr wrap="square" lIns="0" tIns="0" rIns="0" bIns="0" anchor="t">
             <a:spAutoFit/>
           </a:bodyPr>
           <a:lstStyle/>
@@ -9019,7 +8896,7 @@
           <a:noFill/>
         </p:spPr>
         <p:txBody>
-          <a:bodyPr wrap="square" anchor="t" lIns="0" rIns="0" tIns="0" bIns="0">
+          <a:bodyPr wrap="square" lIns="0" tIns="0" rIns="0" bIns="0" anchor="t">
             <a:spAutoFit/>
           </a:bodyPr>
           <a:lstStyle/>
@@ -9058,7 +8935,7 @@
           <a:noFill/>
         </p:spPr>
         <p:txBody>
-          <a:bodyPr wrap="square" anchor="t" lIns="0" rIns="0" tIns="0" bIns="0">
+          <a:bodyPr wrap="square" lIns="0" tIns="0" rIns="0" bIns="0" anchor="t">
             <a:spAutoFit/>
           </a:bodyPr>
           <a:lstStyle/>
@@ -9120,6 +8997,7 @@
           <a:lstStyle/>
           <a:p>
             <a:pPr algn="ctr"/>
+            <a:endParaRPr/>
           </a:p>
         </p:txBody>
       </p:sp>
@@ -9140,7 +9018,7 @@
           <a:noFill/>
         </p:spPr>
         <p:txBody>
-          <a:bodyPr wrap="square" anchor="t" lIns="0" rIns="0" tIns="0" bIns="0">
+          <a:bodyPr wrap="square" lIns="0" tIns="0" rIns="0" bIns="0" anchor="t">
             <a:spAutoFit/>
           </a:bodyPr>
           <a:lstStyle/>
@@ -9179,7 +9057,7 @@
           <a:noFill/>
         </p:spPr>
         <p:txBody>
-          <a:bodyPr wrap="square" anchor="t" lIns="0" rIns="0" tIns="0" bIns="0">
+          <a:bodyPr wrap="square" lIns="0" tIns="0" rIns="0" bIns="0" anchor="t">
             <a:spAutoFit/>
           </a:bodyPr>
           <a:lstStyle/>
@@ -9241,6 +9119,7 @@
           <a:lstStyle/>
           <a:p>
             <a:pPr algn="ctr"/>
+            <a:endParaRPr/>
           </a:p>
         </p:txBody>
       </p:sp>
@@ -9261,7 +9140,7 @@
           <a:noFill/>
         </p:spPr>
         <p:txBody>
-          <a:bodyPr wrap="square" anchor="t" lIns="0" rIns="0" tIns="0" bIns="0">
+          <a:bodyPr wrap="square" lIns="0" tIns="0" rIns="0" bIns="0" anchor="t">
             <a:spAutoFit/>
           </a:bodyPr>
           <a:lstStyle/>
@@ -9300,7 +9179,7 @@
           <a:noFill/>
         </p:spPr>
         <p:txBody>
-          <a:bodyPr wrap="square" anchor="t" lIns="0" rIns="0" tIns="0" bIns="0">
+          <a:bodyPr wrap="square" lIns="0" tIns="0" rIns="0" bIns="0" anchor="t">
             <a:spAutoFit/>
           </a:bodyPr>
           <a:lstStyle/>
@@ -9362,6 +9241,7 @@
           <a:lstStyle/>
           <a:p>
             <a:pPr algn="ctr"/>
+            <a:endParaRPr/>
           </a:p>
         </p:txBody>
       </p:sp>
@@ -9382,7 +9262,7 @@
           <a:noFill/>
         </p:spPr>
         <p:txBody>
-          <a:bodyPr wrap="square" anchor="t" lIns="0" rIns="0" tIns="0" bIns="0">
+          <a:bodyPr wrap="square" lIns="0" tIns="0" rIns="0" bIns="0" anchor="t">
             <a:spAutoFit/>
           </a:bodyPr>
           <a:lstStyle/>
@@ -9421,7 +9301,7 @@
           <a:noFill/>
         </p:spPr>
         <p:txBody>
-          <a:bodyPr wrap="square" anchor="t" lIns="0" rIns="0" tIns="0" bIns="0">
+          <a:bodyPr wrap="square" lIns="0" tIns="0" rIns="0" bIns="0" anchor="t">
             <a:spAutoFit/>
           </a:bodyPr>
           <a:lstStyle/>
@@ -9483,6 +9363,7 @@
           <a:lstStyle/>
           <a:p>
             <a:pPr algn="ctr"/>
+            <a:endParaRPr/>
           </a:p>
         </p:txBody>
       </p:sp>
@@ -9503,7 +9384,7 @@
           <a:noFill/>
         </p:spPr>
         <p:txBody>
-          <a:bodyPr wrap="square" anchor="t" lIns="0" rIns="0" tIns="0" bIns="0">
+          <a:bodyPr wrap="square" lIns="0" tIns="0" rIns="0" bIns="0" anchor="t">
             <a:spAutoFit/>
           </a:bodyPr>
           <a:lstStyle/>
@@ -9542,7 +9423,7 @@
           <a:noFill/>
         </p:spPr>
         <p:txBody>
-          <a:bodyPr wrap="square" anchor="t" lIns="0" rIns="0" tIns="0" bIns="0">
+          <a:bodyPr wrap="square" lIns="0" tIns="0" rIns="0" bIns="0" anchor="t">
             <a:spAutoFit/>
           </a:bodyPr>
           <a:lstStyle/>
@@ -9604,6 +9485,7 @@
           <a:lstStyle/>
           <a:p>
             <a:pPr algn="ctr"/>
+            <a:endParaRPr/>
           </a:p>
         </p:txBody>
       </p:sp>
@@ -9624,7 +9506,7 @@
           <a:noFill/>
         </p:spPr>
         <p:txBody>
-          <a:bodyPr wrap="square" anchor="t" lIns="0" rIns="0" tIns="0" bIns="0">
+          <a:bodyPr wrap="square" lIns="0" tIns="0" rIns="0" bIns="0" anchor="t">
             <a:spAutoFit/>
           </a:bodyPr>
           <a:lstStyle/>
@@ -9655,7 +9537,7 @@
 </file>
 
 <file path=ppt/slides/slide6.xml><?xml version="1.0" encoding="utf-8"?>
-<p:sld xmlns:a="http://schemas.openxmlformats.org/drawingml/2006/main" xmlns:p="http://schemas.openxmlformats.org/presentationml/2006/main" xmlns:r="http://schemas.openxmlformats.org/officeDocument/2006/relationships">
+<p:sld xmlns:a="http://schemas.openxmlformats.org/drawingml/2006/main" xmlns:r="http://schemas.openxmlformats.org/officeDocument/2006/relationships" xmlns:p="http://schemas.openxmlformats.org/presentationml/2006/main">
   <p:cSld>
     <p:spTree>
       <p:nvGrpSpPr>
@@ -9663,7 +9545,14 @@
         <p:cNvGrpSpPr/>
         <p:nvPr/>
       </p:nvGrpSpPr>
-      <p:grpSpPr/>
+      <p:grpSpPr>
+        <a:xfrm>
+          <a:off x="0" y="0"/>
+          <a:ext cx="0" cy="0"/>
+          <a:chOff x="0" y="0"/>
+          <a:chExt cx="0" cy="0"/>
+        </a:xfrm>
+      </p:grpSpPr>
       <p:sp>
         <p:nvSpPr>
           <p:cNvPr id="2" name="Rectangle 1"/>
@@ -9704,6 +9593,7 @@
           <a:lstStyle/>
           <a:p>
             <a:pPr algn="ctr"/>
+            <a:endParaRPr/>
           </a:p>
         </p:txBody>
       </p:sp>
@@ -9724,7 +9614,7 @@
           <a:noFill/>
         </p:spPr>
         <p:txBody>
-          <a:bodyPr wrap="square" anchor="t" lIns="0" rIns="0" tIns="0" bIns="0">
+          <a:bodyPr wrap="square" lIns="0" tIns="0" rIns="0" bIns="0" anchor="t">
             <a:spAutoFit/>
           </a:bodyPr>
           <a:lstStyle/>
@@ -9786,6 +9676,7 @@
           <a:lstStyle/>
           <a:p>
             <a:pPr algn="ctr"/>
+            <a:endParaRPr/>
           </a:p>
         </p:txBody>
       </p:sp>
@@ -9806,7 +9697,7 @@
           <a:noFill/>
         </p:spPr>
         <p:txBody>
-          <a:bodyPr wrap="square" anchor="t" lIns="0" rIns="0" tIns="0" bIns="0">
+          <a:bodyPr wrap="square" lIns="0" tIns="0" rIns="0" bIns="0" anchor="t">
             <a:spAutoFit/>
           </a:bodyPr>
           <a:lstStyle/>
@@ -9870,6 +9761,7 @@
           <a:lstStyle/>
           <a:p>
             <a:pPr algn="ctr"/>
+            <a:endParaRPr/>
           </a:p>
         </p:txBody>
       </p:sp>
@@ -9890,7 +9782,7 @@
           <a:noFill/>
         </p:spPr>
         <p:txBody>
-          <a:bodyPr wrap="square" anchor="t" lIns="0" rIns="0" tIns="0" bIns="0">
+          <a:bodyPr wrap="square" lIns="0" tIns="0" rIns="0" bIns="0" anchor="t">
             <a:spAutoFit/>
           </a:bodyPr>
           <a:lstStyle/>
@@ -9929,7 +9821,7 @@
           <a:noFill/>
         </p:spPr>
         <p:txBody>
-          <a:bodyPr wrap="square" anchor="t" lIns="0" rIns="0" tIns="0" bIns="0">
+          <a:bodyPr wrap="square" lIns="0" tIns="0" rIns="0" bIns="0" anchor="t">
             <a:spAutoFit/>
           </a:bodyPr>
           <a:lstStyle/>
@@ -10025,6 +9917,7 @@
           <a:lstStyle/>
           <a:p>
             <a:pPr algn="ctr"/>
+            <a:endParaRPr/>
           </a:p>
         </p:txBody>
       </p:sp>
@@ -10045,7 +9938,7 @@
           <a:noFill/>
         </p:spPr>
         <p:txBody>
-          <a:bodyPr wrap="square" anchor="t" lIns="0" rIns="0" tIns="0" bIns="0">
+          <a:bodyPr wrap="square" lIns="0" tIns="0" rIns="0" bIns="0" anchor="t">
             <a:spAutoFit/>
           </a:bodyPr>
           <a:lstStyle/>
@@ -10084,7 +9977,7 @@
           <a:noFill/>
         </p:spPr>
         <p:txBody>
-          <a:bodyPr wrap="square" anchor="t" lIns="0" rIns="0" tIns="0" bIns="0">
+          <a:bodyPr wrap="square" lIns="0" tIns="0" rIns="0" bIns="0" anchor="t">
             <a:spAutoFit/>
           </a:bodyPr>
           <a:lstStyle/>
@@ -10178,6 +10071,7 @@
           <a:lstStyle/>
           <a:p>
             <a:pPr algn="ctr"/>
+            <a:endParaRPr/>
           </a:p>
         </p:txBody>
       </p:sp>
@@ -10221,6 +10115,7 @@
           <a:lstStyle/>
           <a:p>
             <a:pPr algn="ctr"/>
+            <a:endParaRPr/>
           </a:p>
         </p:txBody>
       </p:sp>
@@ -10241,7 +10136,7 @@
           <a:noFill/>
         </p:spPr>
         <p:txBody>
-          <a:bodyPr wrap="square" anchor="t" lIns="0" rIns="0" tIns="0" bIns="0">
+          <a:bodyPr wrap="square" lIns="0" tIns="0" rIns="0" bIns="0" anchor="t">
             <a:spAutoFit/>
           </a:bodyPr>
           <a:lstStyle/>
@@ -10280,7 +10175,7 @@
           <a:noFill/>
         </p:spPr>
         <p:txBody>
-          <a:bodyPr wrap="square" anchor="t" lIns="0" rIns="0" tIns="0" bIns="0">
+          <a:bodyPr wrap="square" lIns="0" tIns="0" rIns="0" bIns="0" anchor="t">
             <a:spAutoFit/>
           </a:bodyPr>
           <a:lstStyle/>
@@ -10327,7 +10222,7 @@
 </file>
 
 <file path=ppt/slides/slide7.xml><?xml version="1.0" encoding="utf-8"?>
-<p:sld xmlns:a="http://schemas.openxmlformats.org/drawingml/2006/main" xmlns:p="http://schemas.openxmlformats.org/presentationml/2006/main" xmlns:r="http://schemas.openxmlformats.org/officeDocument/2006/relationships">
+<p:sld xmlns:a="http://schemas.openxmlformats.org/drawingml/2006/main" xmlns:r="http://schemas.openxmlformats.org/officeDocument/2006/relationships" xmlns:p="http://schemas.openxmlformats.org/presentationml/2006/main">
   <p:cSld>
     <p:spTree>
       <p:nvGrpSpPr>
@@ -10335,7 +10230,14 @@
         <p:cNvGrpSpPr/>
         <p:nvPr/>
       </p:nvGrpSpPr>
-      <p:grpSpPr/>
+      <p:grpSpPr>
+        <a:xfrm>
+          <a:off x="0" y="0"/>
+          <a:ext cx="0" cy="0"/>
+          <a:chOff x="0" y="0"/>
+          <a:chExt cx="0" cy="0"/>
+        </a:xfrm>
+      </p:grpSpPr>
       <p:sp>
         <p:nvSpPr>
           <p:cNvPr id="2" name="Rectangle 1"/>
@@ -10376,6 +10278,7 @@
           <a:lstStyle/>
           <a:p>
             <a:pPr algn="ctr"/>
+            <a:endParaRPr/>
           </a:p>
         </p:txBody>
       </p:sp>
@@ -10396,7 +10299,7 @@
           <a:noFill/>
         </p:spPr>
         <p:txBody>
-          <a:bodyPr wrap="square" anchor="t" lIns="0" rIns="0" tIns="0" bIns="0">
+          <a:bodyPr wrap="square" lIns="0" tIns="0" rIns="0" bIns="0" anchor="t">
             <a:spAutoFit/>
           </a:bodyPr>
           <a:lstStyle/>
@@ -10458,6 +10361,7 @@
           <a:lstStyle/>
           <a:p>
             <a:pPr algn="ctr"/>
+            <a:endParaRPr/>
           </a:p>
         </p:txBody>
       </p:sp>
@@ -10478,7 +10382,7 @@
           <a:noFill/>
         </p:spPr>
         <p:txBody>
-          <a:bodyPr wrap="square" anchor="t" lIns="0" rIns="0" tIns="0" bIns="0">
+          <a:bodyPr wrap="square" lIns="0" tIns="0" rIns="0" bIns="0" anchor="t">
             <a:spAutoFit/>
           </a:bodyPr>
           <a:lstStyle/>
@@ -10517,7 +10421,7 @@
           <a:noFill/>
         </p:spPr>
         <p:txBody>
-          <a:bodyPr wrap="square" anchor="t" lIns="0" rIns="0" tIns="0" bIns="0">
+          <a:bodyPr wrap="square" lIns="0" tIns="0" rIns="0" bIns="0" anchor="t">
             <a:spAutoFit/>
           </a:bodyPr>
           <a:lstStyle/>
@@ -10581,6 +10485,7 @@
           <a:lstStyle/>
           <a:p>
             <a:pPr algn="ctr"/>
+            <a:endParaRPr/>
           </a:p>
         </p:txBody>
       </p:sp>
@@ -10601,7 +10506,7 @@
           <a:noFill/>
         </p:spPr>
         <p:txBody>
-          <a:bodyPr wrap="square" anchor="t" lIns="0" rIns="0" tIns="0" bIns="0">
+          <a:bodyPr wrap="square" lIns="0" tIns="0" rIns="0" bIns="0" anchor="t">
             <a:spAutoFit/>
           </a:bodyPr>
           <a:lstStyle/>
@@ -10663,6 +10568,7 @@
           <a:lstStyle/>
           <a:p>
             <a:pPr algn="ctr"/>
+            <a:endParaRPr/>
           </a:p>
         </p:txBody>
       </p:sp>
@@ -10683,7 +10589,7 @@
           <a:noFill/>
         </p:spPr>
         <p:txBody>
-          <a:bodyPr wrap="square" anchor="t" lIns="0" rIns="0" tIns="0" bIns="0">
+          <a:bodyPr wrap="square" lIns="0" tIns="0" rIns="0" bIns="0" anchor="t">
             <a:spAutoFit/>
           </a:bodyPr>
           <a:lstStyle/>
@@ -10722,7 +10628,7 @@
           <a:noFill/>
         </p:spPr>
         <p:txBody>
-          <a:bodyPr wrap="square" anchor="t" lIns="0" rIns="0" tIns="0" bIns="0">
+          <a:bodyPr wrap="square" lIns="0" tIns="0" rIns="0" bIns="0" anchor="t">
             <a:spAutoFit/>
           </a:bodyPr>
           <a:lstStyle/>
@@ -10802,6 +10708,7 @@
           <a:lstStyle/>
           <a:p>
             <a:pPr algn="ctr"/>
+            <a:endParaRPr/>
           </a:p>
         </p:txBody>
       </p:sp>
@@ -10822,7 +10729,7 @@
           <a:noFill/>
         </p:spPr>
         <p:txBody>
-          <a:bodyPr wrap="square" anchor="t" lIns="0" rIns="0" tIns="0" bIns="0">
+          <a:bodyPr wrap="square" lIns="0" tIns="0" rIns="0" bIns="0" anchor="t">
             <a:spAutoFit/>
           </a:bodyPr>
           <a:lstStyle/>
@@ -10884,6 +10791,7 @@
           <a:lstStyle/>
           <a:p>
             <a:pPr algn="ctr"/>
+            <a:endParaRPr/>
           </a:p>
         </p:txBody>
       </p:sp>
@@ -10904,7 +10812,7 @@
           <a:noFill/>
         </p:spPr>
         <p:txBody>
-          <a:bodyPr wrap="square" anchor="t" lIns="0" rIns="0" tIns="0" bIns="0">
+          <a:bodyPr wrap="square" lIns="0" tIns="0" rIns="0" bIns="0" anchor="t">
             <a:spAutoFit/>
           </a:bodyPr>
           <a:lstStyle/>
@@ -10943,7 +10851,7 @@
           <a:noFill/>
         </p:spPr>
         <p:txBody>
-          <a:bodyPr wrap="square" anchor="t" lIns="0" rIns="0" tIns="0" bIns="0">
+          <a:bodyPr wrap="square" lIns="0" tIns="0" rIns="0" bIns="0" anchor="t">
             <a:spAutoFit/>
           </a:bodyPr>
           <a:lstStyle/>
@@ -11023,6 +10931,7 @@
           <a:lstStyle/>
           <a:p>
             <a:pPr algn="ctr"/>
+            <a:endParaRPr/>
           </a:p>
         </p:txBody>
       </p:sp>
@@ -11043,7 +10952,7 @@
           <a:noFill/>
         </p:spPr>
         <p:txBody>
-          <a:bodyPr wrap="square" anchor="t" lIns="0" rIns="0" tIns="0" bIns="0">
+          <a:bodyPr wrap="square" lIns="0" tIns="0" rIns="0" bIns="0" anchor="t">
             <a:spAutoFit/>
           </a:bodyPr>
           <a:lstStyle/>
@@ -11105,6 +11014,7 @@
           <a:lstStyle/>
           <a:p>
             <a:pPr algn="ctr"/>
+            <a:endParaRPr/>
           </a:p>
         </p:txBody>
       </p:sp>
@@ -11125,7 +11035,7 @@
           <a:noFill/>
         </p:spPr>
         <p:txBody>
-          <a:bodyPr wrap="square" anchor="t" lIns="0" rIns="0" tIns="0" bIns="0">
+          <a:bodyPr wrap="square" lIns="0" tIns="0" rIns="0" bIns="0" anchor="t">
             <a:spAutoFit/>
           </a:bodyPr>
           <a:lstStyle/>
@@ -11164,7 +11074,7 @@
           <a:noFill/>
         </p:spPr>
         <p:txBody>
-          <a:bodyPr wrap="square" anchor="t" lIns="0" rIns="0" tIns="0" bIns="0">
+          <a:bodyPr wrap="square" lIns="0" tIns="0" rIns="0" bIns="0" anchor="t">
             <a:spAutoFit/>
           </a:bodyPr>
           <a:lstStyle/>
@@ -11242,6 +11152,7 @@
           <a:lstStyle/>
           <a:p>
             <a:pPr algn="ctr"/>
+            <a:endParaRPr/>
           </a:p>
         </p:txBody>
       </p:sp>
@@ -11262,7 +11173,7 @@
           <a:noFill/>
         </p:spPr>
         <p:txBody>
-          <a:bodyPr wrap="square" anchor="t" lIns="0" rIns="0" tIns="0" bIns="0">
+          <a:bodyPr wrap="square" lIns="0" tIns="0" rIns="0" bIns="0" anchor="t">
             <a:spAutoFit/>
           </a:bodyPr>
           <a:lstStyle/>
@@ -11293,7 +11204,7 @@
 </file>
 
 <file path=ppt/slides/slide8.xml><?xml version="1.0" encoding="utf-8"?>
-<p:sld xmlns:a="http://schemas.openxmlformats.org/drawingml/2006/main" xmlns:p="http://schemas.openxmlformats.org/presentationml/2006/main" xmlns:r="http://schemas.openxmlformats.org/officeDocument/2006/relationships">
+<p:sld xmlns:a="http://schemas.openxmlformats.org/drawingml/2006/main" xmlns:r="http://schemas.openxmlformats.org/officeDocument/2006/relationships" xmlns:p="http://schemas.openxmlformats.org/presentationml/2006/main">
   <p:cSld>
     <p:spTree>
       <p:nvGrpSpPr>
@@ -11301,7 +11212,14 @@
         <p:cNvGrpSpPr/>
         <p:nvPr/>
       </p:nvGrpSpPr>
-      <p:grpSpPr/>
+      <p:grpSpPr>
+        <a:xfrm>
+          <a:off x="0" y="0"/>
+          <a:ext cx="0" cy="0"/>
+          <a:chOff x="0" y="0"/>
+          <a:chExt cx="0" cy="0"/>
+        </a:xfrm>
+      </p:grpSpPr>
       <p:sp>
         <p:nvSpPr>
           <p:cNvPr id="2" name="Rectangle 1"/>
@@ -11342,6 +11260,7 @@
           <a:lstStyle/>
           <a:p>
             <a:pPr algn="ctr"/>
+            <a:endParaRPr/>
           </a:p>
         </p:txBody>
       </p:sp>
@@ -11362,7 +11281,7 @@
           <a:noFill/>
         </p:spPr>
         <p:txBody>
-          <a:bodyPr wrap="square" anchor="t" lIns="0" rIns="0" tIns="0" bIns="0">
+          <a:bodyPr wrap="square" lIns="0" tIns="0" rIns="0" bIns="0" anchor="t">
             <a:spAutoFit/>
           </a:bodyPr>
           <a:lstStyle/>
@@ -11424,6 +11343,7 @@
           <a:lstStyle/>
           <a:p>
             <a:pPr algn="ctr"/>
+            <a:endParaRPr/>
           </a:p>
         </p:txBody>
       </p:sp>
@@ -11444,7 +11364,7 @@
           <a:noFill/>
         </p:spPr>
         <p:txBody>
-          <a:bodyPr wrap="square" anchor="t" lIns="0" rIns="0" tIns="0" bIns="0">
+          <a:bodyPr wrap="square" lIns="0" tIns="0" rIns="0" bIns="0" anchor="t">
             <a:spAutoFit/>
           </a:bodyPr>
           <a:lstStyle/>
@@ -11506,6 +11426,7 @@
           <a:lstStyle/>
           <a:p>
             <a:pPr algn="ctr"/>
+            <a:endParaRPr/>
           </a:p>
         </p:txBody>
       </p:sp>
@@ -11526,7 +11447,7 @@
           <a:noFill/>
         </p:spPr>
         <p:txBody>
-          <a:bodyPr wrap="square" anchor="t" lIns="0" rIns="0" tIns="0" bIns="0">
+          <a:bodyPr wrap="square" lIns="0" tIns="0" rIns="0" bIns="0" anchor="t">
             <a:spAutoFit/>
           </a:bodyPr>
           <a:lstStyle/>
@@ -11565,7 +11486,7 @@
           <a:noFill/>
         </p:spPr>
         <p:txBody>
-          <a:bodyPr wrap="square" anchor="t" lIns="0" rIns="0" tIns="0" bIns="0">
+          <a:bodyPr wrap="square" lIns="0" tIns="0" rIns="0" bIns="0" anchor="t">
             <a:spAutoFit/>
           </a:bodyPr>
           <a:lstStyle/>
@@ -11604,7 +11525,7 @@
           <a:noFill/>
         </p:spPr>
         <p:txBody>
-          <a:bodyPr wrap="square" anchor="t" lIns="0" rIns="0" tIns="0" bIns="0">
+          <a:bodyPr wrap="square" lIns="0" tIns="0" rIns="0" bIns="0" anchor="t">
             <a:spAutoFit/>
           </a:bodyPr>
           <a:lstStyle/>
@@ -11666,6 +11587,7 @@
           <a:lstStyle/>
           <a:p>
             <a:pPr algn="ctr"/>
+            <a:endParaRPr/>
           </a:p>
         </p:txBody>
       </p:sp>
@@ -11686,7 +11608,7 @@
           <a:noFill/>
         </p:spPr>
         <p:txBody>
-          <a:bodyPr wrap="square" anchor="t" lIns="0" rIns="0" tIns="0" bIns="0">
+          <a:bodyPr wrap="square" lIns="0" tIns="0" rIns="0" bIns="0" anchor="t">
             <a:spAutoFit/>
           </a:bodyPr>
           <a:lstStyle/>
@@ -11725,7 +11647,7 @@
           <a:noFill/>
         </p:spPr>
         <p:txBody>
-          <a:bodyPr wrap="square" anchor="t" lIns="0" rIns="0" tIns="0" bIns="0">
+          <a:bodyPr wrap="square" lIns="0" tIns="0" rIns="0" bIns="0" anchor="t">
             <a:spAutoFit/>
           </a:bodyPr>
           <a:lstStyle/>
@@ -11764,7 +11686,7 @@
           <a:noFill/>
         </p:spPr>
         <p:txBody>
-          <a:bodyPr wrap="square" anchor="t" lIns="0" rIns="0" tIns="0" bIns="0">
+          <a:bodyPr wrap="square" lIns="0" tIns="0" rIns="0" bIns="0" anchor="t">
             <a:spAutoFit/>
           </a:bodyPr>
           <a:lstStyle/>
@@ -11803,7 +11725,7 @@
           <a:noFill/>
         </p:spPr>
         <p:txBody>
-          <a:bodyPr wrap="square" anchor="t" lIns="0" rIns="0" tIns="0" bIns="0">
+          <a:bodyPr wrap="square" lIns="0" tIns="0" rIns="0" bIns="0" anchor="t">
             <a:spAutoFit/>
           </a:bodyPr>
           <a:lstStyle/>
@@ -11842,7 +11764,7 @@
           <a:noFill/>
         </p:spPr>
         <p:txBody>
-          <a:bodyPr wrap="square" anchor="t" lIns="0" rIns="0" tIns="0" bIns="0">
+          <a:bodyPr wrap="square" lIns="0" tIns="0" rIns="0" bIns="0" anchor="t">
             <a:spAutoFit/>
           </a:bodyPr>
           <a:lstStyle/>
@@ -11904,6 +11826,7 @@
           <a:lstStyle/>
           <a:p>
             <a:pPr algn="ctr"/>
+            <a:endParaRPr/>
           </a:p>
         </p:txBody>
       </p:sp>
@@ -11924,7 +11847,7 @@
           <a:noFill/>
         </p:spPr>
         <p:txBody>
-          <a:bodyPr wrap="square" anchor="t" lIns="0" rIns="0" tIns="0" bIns="0">
+          <a:bodyPr wrap="square" lIns="0" tIns="0" rIns="0" bIns="0" anchor="t">
             <a:spAutoFit/>
           </a:bodyPr>
           <a:lstStyle/>
@@ -11935,7 +11858,7 @@
               </a:lnSpc>
             </a:pPr>
             <a:r>
-              <a:rPr sz="1450" b="1">
+              <a:rPr sz="1450" b="1" dirty="0">
                 <a:solidFill>
                   <a:srgbClr val="000000"/>
                 </a:solidFill>
@@ -11963,7 +11886,7 @@
           <a:noFill/>
         </p:spPr>
         <p:txBody>
-          <a:bodyPr wrap="square" anchor="t" lIns="0" rIns="0" tIns="0" bIns="0">
+          <a:bodyPr wrap="square" lIns="0" tIns="0" rIns="0" bIns="0" anchor="t">
             <a:spAutoFit/>
           </a:bodyPr>
           <a:lstStyle/>
@@ -12002,7 +11925,7 @@
           <a:noFill/>
         </p:spPr>
         <p:txBody>
-          <a:bodyPr wrap="square" anchor="t" lIns="0" rIns="0" tIns="0" bIns="0">
+          <a:bodyPr wrap="square" lIns="0" tIns="0" rIns="0" bIns="0" anchor="t">
             <a:spAutoFit/>
           </a:bodyPr>
           <a:lstStyle/>
@@ -12013,7 +11936,7 @@
               </a:lnSpc>
             </a:pPr>
             <a:r>
-              <a:rPr sz="1250" b="0">
+              <a:rPr sz="1250" b="0" dirty="0">
                 <a:solidFill>
                   <a:srgbClr val="000000"/>
                 </a:solidFill>
@@ -12041,7 +11964,7 @@
           <a:noFill/>
         </p:spPr>
         <p:txBody>
-          <a:bodyPr wrap="square" anchor="t" lIns="0" rIns="0" tIns="0" bIns="0">
+          <a:bodyPr wrap="square" lIns="0" tIns="0" rIns="0" bIns="0" anchor="t">
             <a:spAutoFit/>
           </a:bodyPr>
           <a:lstStyle/>
@@ -12052,7 +11975,7 @@
               </a:lnSpc>
             </a:pPr>
             <a:r>
-              <a:rPr sz="1250" b="0">
+              <a:rPr sz="1250" b="0" dirty="0">
                 <a:solidFill>
                   <a:srgbClr val="000000"/>
                 </a:solidFill>
@@ -12080,7 +12003,7 @@
           <a:noFill/>
         </p:spPr>
         <p:txBody>
-          <a:bodyPr wrap="square" anchor="t" lIns="0" rIns="0" tIns="0" bIns="0">
+          <a:bodyPr wrap="square" lIns="0" tIns="0" rIns="0" bIns="0" anchor="t">
             <a:spAutoFit/>
           </a:bodyPr>
           <a:lstStyle/>
@@ -12110,8 +12033,8 @@
         </p:nvSpPr>
         <p:spPr>
           <a:xfrm>
-            <a:off x="566928" y="4114800"/>
-            <a:ext cx="8046720" cy="310896"/>
+            <a:off x="4782312" y="2879105"/>
+            <a:ext cx="3977640" cy="640079"/>
           </a:xfrm>
           <a:prstGeom prst="rect">
             <a:avLst/>
@@ -12144,6 +12067,7 @@
           <a:lstStyle/>
           <a:p>
             <a:pPr algn="ctr"/>
+            <a:endParaRPr/>
           </a:p>
         </p:txBody>
       </p:sp>
@@ -12155,8 +12079,8 @@
         </p:nvSpPr>
         <p:spPr>
           <a:xfrm>
-            <a:off x="777240" y="4178808"/>
-            <a:ext cx="7589520" cy="228600"/>
+            <a:off x="4873752" y="2943113"/>
+            <a:ext cx="3831336" cy="384721"/>
           </a:xfrm>
           <a:prstGeom prst="rect">
             <a:avLst/>
@@ -12164,7 +12088,7 @@
           <a:noFill/>
         </p:spPr>
         <p:txBody>
-          <a:bodyPr wrap="square" anchor="t" lIns="0" rIns="0" tIns="0" bIns="0">
+          <a:bodyPr wrap="square" lIns="0" tIns="0" rIns="0" bIns="0" anchor="t">
             <a:spAutoFit/>
           </a:bodyPr>
           <a:lstStyle/>
@@ -12175,7 +12099,7 @@
               </a:lnSpc>
             </a:pPr>
             <a:r>
-              <a:rPr sz="1250" b="0">
+              <a:rPr sz="1250" b="0" dirty="0">
                 <a:solidFill>
                   <a:srgbClr val="000000"/>
                 </a:solidFill>
@@ -12194,8 +12118,8 @@
         </p:nvSpPr>
         <p:spPr>
           <a:xfrm>
-            <a:off x="566928" y="4480560"/>
-            <a:ext cx="8046720" cy="310896"/>
+            <a:off x="4782312" y="3734067"/>
+            <a:ext cx="3977640" cy="678012"/>
           </a:xfrm>
           <a:prstGeom prst="rect">
             <a:avLst/>
@@ -12228,6 +12152,7 @@
           <a:lstStyle/>
           <a:p>
             <a:pPr algn="ctr"/>
+            <a:endParaRPr/>
           </a:p>
         </p:txBody>
       </p:sp>
@@ -12239,8 +12164,8 @@
         </p:nvSpPr>
         <p:spPr>
           <a:xfrm>
-            <a:off x="777240" y="4544568"/>
-            <a:ext cx="7589520" cy="228600"/>
+            <a:off x="4860036" y="3815009"/>
+            <a:ext cx="3808476" cy="384721"/>
           </a:xfrm>
           <a:prstGeom prst="rect">
             <a:avLst/>
@@ -12248,7 +12173,7 @@
           <a:noFill/>
         </p:spPr>
         <p:txBody>
-          <a:bodyPr wrap="square" anchor="t" lIns="0" rIns="0" tIns="0" bIns="0">
+          <a:bodyPr wrap="square" lIns="0" tIns="0" rIns="0" bIns="0" anchor="t">
             <a:spAutoFit/>
           </a:bodyPr>
           <a:lstStyle/>
@@ -12259,7 +12184,7 @@
               </a:lnSpc>
             </a:pPr>
             <a:r>
-              <a:rPr sz="1250" b="0">
+              <a:rPr sz="1250" b="0" dirty="0">
                 <a:solidFill>
                   <a:srgbClr val="000000"/>
                 </a:solidFill>
@@ -12279,7 +12204,7 @@
 </file>
 
 <file path=ppt/slides/slide9.xml><?xml version="1.0" encoding="utf-8"?>
-<p:sld xmlns:a="http://schemas.openxmlformats.org/drawingml/2006/main" xmlns:p="http://schemas.openxmlformats.org/presentationml/2006/main" xmlns:r="http://schemas.openxmlformats.org/officeDocument/2006/relationships">
+<p:sld xmlns:a="http://schemas.openxmlformats.org/drawingml/2006/main" xmlns:r="http://schemas.openxmlformats.org/officeDocument/2006/relationships" xmlns:p="http://schemas.openxmlformats.org/presentationml/2006/main">
   <p:cSld>
     <p:spTree>
       <p:nvGrpSpPr>
@@ -12287,7 +12212,14 @@
         <p:cNvGrpSpPr/>
         <p:nvPr/>
       </p:nvGrpSpPr>
-      <p:grpSpPr/>
+      <p:grpSpPr>
+        <a:xfrm>
+          <a:off x="0" y="0"/>
+          <a:ext cx="0" cy="0"/>
+          <a:chOff x="0" y="0"/>
+          <a:chExt cx="0" cy="0"/>
+        </a:xfrm>
+      </p:grpSpPr>
       <p:sp>
         <p:nvSpPr>
           <p:cNvPr id="2" name="Rectangle 1"/>
@@ -12328,6 +12260,7 @@
           <a:lstStyle/>
           <a:p>
             <a:pPr algn="ctr"/>
+            <a:endParaRPr/>
           </a:p>
         </p:txBody>
       </p:sp>
@@ -12348,7 +12281,7 @@
           <a:noFill/>
         </p:spPr>
         <p:txBody>
-          <a:bodyPr wrap="square" anchor="t" lIns="0" rIns="0" tIns="0" bIns="0">
+          <a:bodyPr wrap="square" lIns="0" tIns="0" rIns="0" bIns="0" anchor="t">
             <a:spAutoFit/>
           </a:bodyPr>
           <a:lstStyle/>
@@ -12410,6 +12343,7 @@
           <a:lstStyle/>
           <a:p>
             <a:pPr algn="ctr"/>
+            <a:endParaRPr/>
           </a:p>
         </p:txBody>
       </p:sp>
@@ -12430,7 +12364,7 @@
           <a:noFill/>
         </p:spPr>
         <p:txBody>
-          <a:bodyPr wrap="square" anchor="t" lIns="0" rIns="0" tIns="0" bIns="0">
+          <a:bodyPr wrap="square" lIns="0" tIns="0" rIns="0" bIns="0" anchor="t">
             <a:spAutoFit/>
           </a:bodyPr>
           <a:lstStyle/>
@@ -12494,6 +12428,7 @@
           <a:lstStyle/>
           <a:p>
             <a:pPr algn="ctr"/>
+            <a:endParaRPr/>
           </a:p>
         </p:txBody>
       </p:sp>
@@ -12537,6 +12472,7 @@
           <a:lstStyle/>
           <a:p>
             <a:pPr algn="ctr"/>
+            <a:endParaRPr/>
           </a:p>
         </p:txBody>
       </p:sp>
@@ -12557,7 +12493,7 @@
           <a:noFill/>
         </p:spPr>
         <p:txBody>
-          <a:bodyPr wrap="square" anchor="t" lIns="0" rIns="0" tIns="0" bIns="0">
+          <a:bodyPr wrap="square" lIns="0" tIns="0" rIns="0" bIns="0" anchor="t">
             <a:spAutoFit/>
           </a:bodyPr>
           <a:lstStyle/>
@@ -12596,7 +12532,7 @@
           <a:noFill/>
         </p:spPr>
         <p:txBody>
-          <a:bodyPr wrap="square" anchor="t" lIns="0" rIns="0" tIns="0" bIns="0">
+          <a:bodyPr wrap="square" lIns="0" tIns="0" rIns="0" bIns="0" anchor="t">
             <a:spAutoFit/>
           </a:bodyPr>
           <a:lstStyle/>
@@ -12660,6 +12596,7 @@
           <a:lstStyle/>
           <a:p>
             <a:pPr algn="ctr"/>
+            <a:endParaRPr/>
           </a:p>
         </p:txBody>
       </p:sp>
@@ -12703,6 +12640,7 @@
           <a:lstStyle/>
           <a:p>
             <a:pPr algn="ctr"/>
+            <a:endParaRPr/>
           </a:p>
         </p:txBody>
       </p:sp>
@@ -12723,7 +12661,7 @@
           <a:noFill/>
         </p:spPr>
         <p:txBody>
-          <a:bodyPr wrap="square" anchor="t" lIns="0" rIns="0" tIns="0" bIns="0">
+          <a:bodyPr wrap="square" lIns="0" tIns="0" rIns="0" bIns="0" anchor="t">
             <a:spAutoFit/>
           </a:bodyPr>
           <a:lstStyle/>
@@ -12762,7 +12700,7 @@
           <a:noFill/>
         </p:spPr>
         <p:txBody>
-          <a:bodyPr wrap="square" anchor="t" lIns="0" rIns="0" tIns="0" bIns="0">
+          <a:bodyPr wrap="square" lIns="0" tIns="0" rIns="0" bIns="0" anchor="t">
             <a:spAutoFit/>
           </a:bodyPr>
           <a:lstStyle/>
@@ -12826,6 +12764,7 @@
           <a:lstStyle/>
           <a:p>
             <a:pPr algn="ctr"/>
+            <a:endParaRPr/>
           </a:p>
         </p:txBody>
       </p:sp>
@@ -12869,6 +12808,7 @@
           <a:lstStyle/>
           <a:p>
             <a:pPr algn="ctr"/>
+            <a:endParaRPr/>
           </a:p>
         </p:txBody>
       </p:sp>
@@ -12889,7 +12829,7 @@
           <a:noFill/>
         </p:spPr>
         <p:txBody>
-          <a:bodyPr wrap="square" anchor="t" lIns="0" rIns="0" tIns="0" bIns="0">
+          <a:bodyPr wrap="square" lIns="0" tIns="0" rIns="0" bIns="0" anchor="t">
             <a:spAutoFit/>
           </a:bodyPr>
           <a:lstStyle/>
@@ -12928,7 +12868,7 @@
           <a:noFill/>
         </p:spPr>
         <p:txBody>
-          <a:bodyPr wrap="square" anchor="t" lIns="0" rIns="0" tIns="0" bIns="0">
+          <a:bodyPr wrap="square" lIns="0" tIns="0" rIns="0" bIns="0" anchor="t">
             <a:spAutoFit/>
           </a:bodyPr>
           <a:lstStyle/>
@@ -12992,6 +12932,7 @@
           <a:lstStyle/>
           <a:p>
             <a:pPr algn="ctr"/>
+            <a:endParaRPr/>
           </a:p>
         </p:txBody>
       </p:sp>
@@ -13035,6 +12976,7 @@
           <a:lstStyle/>
           <a:p>
             <a:pPr algn="ctr"/>
+            <a:endParaRPr/>
           </a:p>
         </p:txBody>
       </p:sp>
@@ -13055,7 +12997,7 @@
           <a:noFill/>
         </p:spPr>
         <p:txBody>
-          <a:bodyPr wrap="square" anchor="t" lIns="0" rIns="0" tIns="0" bIns="0">
+          <a:bodyPr wrap="square" lIns="0" tIns="0" rIns="0" bIns="0" anchor="t">
             <a:spAutoFit/>
           </a:bodyPr>
           <a:lstStyle/>
@@ -13094,7 +13036,7 @@
           <a:noFill/>
         </p:spPr>
         <p:txBody>
-          <a:bodyPr wrap="square" anchor="t" lIns="0" rIns="0" tIns="0" bIns="0">
+          <a:bodyPr wrap="square" lIns="0" tIns="0" rIns="0" bIns="0" anchor="t">
             <a:spAutoFit/>
           </a:bodyPr>
           <a:lstStyle/>
@@ -13158,6 +13100,7 @@
           <a:lstStyle/>
           <a:p>
             <a:pPr algn="ctr"/>
+            <a:endParaRPr/>
           </a:p>
         </p:txBody>
       </p:sp>
@@ -13201,6 +13144,7 @@
           <a:lstStyle/>
           <a:p>
             <a:pPr algn="ctr"/>
+            <a:endParaRPr/>
           </a:p>
         </p:txBody>
       </p:sp>
@@ -13221,7 +13165,7 @@
           <a:noFill/>
         </p:spPr>
         <p:txBody>
-          <a:bodyPr wrap="square" anchor="t" lIns="0" rIns="0" tIns="0" bIns="0">
+          <a:bodyPr wrap="square" lIns="0" tIns="0" rIns="0" bIns="0" anchor="t">
             <a:spAutoFit/>
           </a:bodyPr>
           <a:lstStyle/>
@@ -13260,7 +13204,7 @@
           <a:noFill/>
         </p:spPr>
         <p:txBody>
-          <a:bodyPr wrap="square" anchor="t" lIns="0" rIns="0" tIns="0" bIns="0">
+          <a:bodyPr wrap="square" lIns="0" tIns="0" rIns="0" bIns="0" anchor="t">
             <a:spAutoFit/>
           </a:bodyPr>
           <a:lstStyle/>
@@ -13324,6 +13268,7 @@
           <a:lstStyle/>
           <a:p>
             <a:pPr algn="ctr"/>
+            <a:endParaRPr/>
           </a:p>
         </p:txBody>
       </p:sp>
@@ -13367,6 +13312,7 @@
           <a:lstStyle/>
           <a:p>
             <a:pPr algn="ctr"/>
+            <a:endParaRPr/>
           </a:p>
         </p:txBody>
       </p:sp>
@@ -13387,7 +13333,7 @@
           <a:noFill/>
         </p:spPr>
         <p:txBody>
-          <a:bodyPr wrap="square" anchor="t" lIns="0" rIns="0" tIns="0" bIns="0">
+          <a:bodyPr wrap="square" lIns="0" tIns="0" rIns="0" bIns="0" anchor="t">
             <a:spAutoFit/>
           </a:bodyPr>
           <a:lstStyle/>
@@ -13426,7 +13372,7 @@
           <a:noFill/>
         </p:spPr>
         <p:txBody>
-          <a:bodyPr wrap="square" anchor="t" lIns="0" rIns="0" tIns="0" bIns="0">
+          <a:bodyPr wrap="square" lIns="0" tIns="0" rIns="0" bIns="0" anchor="t">
             <a:spAutoFit/>
           </a:bodyPr>
           <a:lstStyle/>
@@ -13490,6 +13436,7 @@
           <a:lstStyle/>
           <a:p>
             <a:pPr algn="ctr"/>
+            <a:endParaRPr/>
           </a:p>
         </p:txBody>
       </p:sp>
@@ -13533,6 +13480,7 @@
           <a:lstStyle/>
           <a:p>
             <a:pPr algn="ctr"/>
+            <a:endParaRPr/>
           </a:p>
         </p:txBody>
       </p:sp>
@@ -13553,7 +13501,7 @@
           <a:noFill/>
         </p:spPr>
         <p:txBody>
-          <a:bodyPr wrap="square" anchor="t" lIns="0" rIns="0" tIns="0" bIns="0">
+          <a:bodyPr wrap="square" lIns="0" tIns="0" rIns="0" bIns="0" anchor="t">
             <a:spAutoFit/>
           </a:bodyPr>
           <a:lstStyle/>
@@ -13592,7 +13540,7 @@
           <a:noFill/>
         </p:spPr>
         <p:txBody>
-          <a:bodyPr wrap="square" anchor="t" lIns="0" rIns="0" tIns="0" bIns="0">
+          <a:bodyPr wrap="square" lIns="0" tIns="0" rIns="0" bIns="0" anchor="t">
             <a:spAutoFit/>
           </a:bodyPr>
           <a:lstStyle/>
@@ -13656,6 +13604,7 @@
           <a:lstStyle/>
           <a:p>
             <a:pPr algn="ctr"/>
+            <a:endParaRPr/>
           </a:p>
         </p:txBody>
       </p:sp>
@@ -13699,6 +13648,7 @@
           <a:lstStyle/>
           <a:p>
             <a:pPr algn="ctr"/>
+            <a:endParaRPr/>
           </a:p>
         </p:txBody>
       </p:sp>
@@ -13719,7 +13669,7 @@
           <a:noFill/>
         </p:spPr>
         <p:txBody>
-          <a:bodyPr wrap="square" anchor="t" lIns="0" rIns="0" tIns="0" bIns="0">
+          <a:bodyPr wrap="square" lIns="0" tIns="0" rIns="0" bIns="0" anchor="t">
             <a:spAutoFit/>
           </a:bodyPr>
           <a:lstStyle/>
@@ -13758,7 +13708,7 @@
           <a:noFill/>
         </p:spPr>
         <p:txBody>
-          <a:bodyPr wrap="square" anchor="t" lIns="0" rIns="0" tIns="0" bIns="0">
+          <a:bodyPr wrap="square" lIns="0" tIns="0" rIns="0" bIns="0" anchor="t">
             <a:spAutoFit/>
           </a:bodyPr>
           <a:lstStyle/>
@@ -13820,6 +13770,7 @@
           <a:lstStyle/>
           <a:p>
             <a:pPr algn="ctr"/>
+            <a:endParaRPr/>
           </a:p>
         </p:txBody>
       </p:sp>
@@ -13840,7 +13791,7 @@
           <a:noFill/>
         </p:spPr>
         <p:txBody>
-          <a:bodyPr wrap="square" anchor="t" lIns="0" rIns="0" tIns="0" bIns="0">
+          <a:bodyPr wrap="square" lIns="0" tIns="0" rIns="0" bIns="0" anchor="t">
             <a:spAutoFit/>
           </a:bodyPr>
           <a:lstStyle/>
@@ -13851,7 +13802,7 @@
               </a:lnSpc>
             </a:pPr>
             <a:r>
-              <a:rPr sz="1400" b="0">
+              <a:rPr sz="1400" b="0" dirty="0">
                 <a:solidFill>
                   <a:srgbClr val="000000"/>
                 </a:solidFill>
@@ -13879,7 +13830,7 @@
           <a:noFill/>
         </p:spPr>
         <p:txBody>
-          <a:bodyPr wrap="square" anchor="t" lIns="0" rIns="0" tIns="0" bIns="0">
+          <a:bodyPr wrap="square" lIns="0" tIns="0" rIns="0" bIns="0" anchor="t">
             <a:spAutoFit/>
           </a:bodyPr>
           <a:lstStyle/>
@@ -14240,44 +14191,44 @@
         <a:sysClr val="window" lastClr="FFFFFF"/>
       </a:lt1>
       <a:dk2>
-        <a:srgbClr val="1F497D"/>
+        <a:srgbClr val="0E2841"/>
       </a:dk2>
       <a:lt2>
-        <a:srgbClr val="EEECE1"/>
+        <a:srgbClr val="E8E8E8"/>
       </a:lt2>
       <a:accent1>
-        <a:srgbClr val="4F81BD"/>
+        <a:srgbClr val="156082"/>
       </a:accent1>
       <a:accent2>
-        <a:srgbClr val="C0504D"/>
+        <a:srgbClr val="E97132"/>
       </a:accent2>
       <a:accent3>
-        <a:srgbClr val="9BBB59"/>
+        <a:srgbClr val="196B24"/>
       </a:accent3>
       <a:accent4>
-        <a:srgbClr val="8064A2"/>
+        <a:srgbClr val="0F9ED5"/>
       </a:accent4>
       <a:accent5>
-        <a:srgbClr val="4BACC6"/>
+        <a:srgbClr val="A02B93"/>
       </a:accent5>
       <a:accent6>
-        <a:srgbClr val="F79646"/>
+        <a:srgbClr val="4EA72E"/>
       </a:accent6>
       <a:hlink>
-        <a:srgbClr val="0000FF"/>
+        <a:srgbClr val="467886"/>
       </a:hlink>
       <a:folHlink>
-        <a:srgbClr val="800080"/>
+        <a:srgbClr val="96607D"/>
       </a:folHlink>
     </a:clrScheme>
     <a:fontScheme name="Office">
       <a:majorFont>
-        <a:latin typeface="Calibri"/>
+        <a:latin typeface="Aptos Display" panose="02110004020202020204"/>
         <a:ea typeface=""/>
         <a:cs typeface=""/>
-        <a:font script="Jpan" typeface="ＭＳ Ｐゴシック"/>
+        <a:font script="Jpan" typeface="游ゴシック Light"/>
         <a:font script="Hang" typeface="맑은 고딕"/>
-        <a:font script="Hans" typeface="宋体"/>
+        <a:font script="Hans" typeface="等线 Light"/>
         <a:font script="Hant" typeface="新細明體"/>
         <a:font script="Arab" typeface="Times New Roman"/>
         <a:font script="Hebr" typeface="Times New Roman"/>
@@ -14305,14 +14256,31 @@
         <a:font script="Viet" typeface="Times New Roman"/>
         <a:font script="Uigh" typeface="Microsoft Uighur"/>
         <a:font script="Geor" typeface="Sylfaen"/>
+        <a:font script="Armn" typeface="Arial"/>
+        <a:font script="Bugi" typeface="Leelawadee UI"/>
+        <a:font script="Bopo" typeface="Microsoft JhengHei"/>
+        <a:font script="Java" typeface="Javanese Text"/>
+        <a:font script="Lisu" typeface="Segoe UI"/>
+        <a:font script="Mymr" typeface="Myanmar Text"/>
+        <a:font script="Nkoo" typeface="Ebrima"/>
+        <a:font script="Olck" typeface="Nirmala UI"/>
+        <a:font script="Osma" typeface="Ebrima"/>
+        <a:font script="Phag" typeface="Phagspa"/>
+        <a:font script="Syrn" typeface="Estrangelo Edessa"/>
+        <a:font script="Syrj" typeface="Estrangelo Edessa"/>
+        <a:font script="Syre" typeface="Estrangelo Edessa"/>
+        <a:font script="Sora" typeface="Nirmala UI"/>
+        <a:font script="Tale" typeface="Microsoft Tai Le"/>
+        <a:font script="Talu" typeface="Microsoft New Tai Lue"/>
+        <a:font script="Tfng" typeface="Ebrima"/>
       </a:majorFont>
       <a:minorFont>
-        <a:latin typeface="Calibri"/>
+        <a:latin typeface="Aptos" panose="02110004020202020204"/>
         <a:ea typeface=""/>
         <a:cs typeface=""/>
-        <a:font script="Jpan" typeface="ＭＳ Ｐゴシック"/>
+        <a:font script="Jpan" typeface="游ゴシック"/>
         <a:font script="Hang" typeface="맑은 고딕"/>
-        <a:font script="Hans" typeface="宋体"/>
+        <a:font script="Hans" typeface="等线"/>
         <a:font script="Hant" typeface="新細明體"/>
         <a:font script="Arab" typeface="Arial"/>
         <a:font script="Hebr" typeface="Arial"/>
@@ -14340,6 +14308,23 @@
         <a:font script="Viet" typeface="Arial"/>
         <a:font script="Uigh" typeface="Microsoft Uighur"/>
         <a:font script="Geor" typeface="Sylfaen"/>
+        <a:font script="Armn" typeface="Arial"/>
+        <a:font script="Bugi" typeface="Leelawadee UI"/>
+        <a:font script="Bopo" typeface="Microsoft JhengHei"/>
+        <a:font script="Java" typeface="Javanese Text"/>
+        <a:font script="Lisu" typeface="Segoe UI"/>
+        <a:font script="Mymr" typeface="Myanmar Text"/>
+        <a:font script="Nkoo" typeface="Ebrima"/>
+        <a:font script="Olck" typeface="Nirmala UI"/>
+        <a:font script="Osma" typeface="Ebrima"/>
+        <a:font script="Phag" typeface="Phagspa"/>
+        <a:font script="Syrn" typeface="Estrangelo Edessa"/>
+        <a:font script="Syrj" typeface="Estrangelo Edessa"/>
+        <a:font script="Syre" typeface="Estrangelo Edessa"/>
+        <a:font script="Sora" typeface="Nirmala UI"/>
+        <a:font script="Tale" typeface="Microsoft Tai Le"/>
+        <a:font script="Talu" typeface="Microsoft New Tai Lue"/>
+        <a:font script="Tfng" typeface="Ebrima"/>
       </a:minorFont>
     </a:fontScheme>
     <a:fmtScheme name="Office">
@@ -14351,180 +14336,136 @@
           <a:gsLst>
             <a:gs pos="0">
               <a:schemeClr val="phClr">
-                <a:tint val="50000"/>
-                <a:satMod val="300000"/>
+                <a:lumMod val="110000"/>
+                <a:satMod val="105000"/>
+                <a:tint val="67000"/>
               </a:schemeClr>
             </a:gs>
-            <a:gs pos="35000">
+            <a:gs pos="50000">
               <a:schemeClr val="phClr">
-                <a:tint val="37000"/>
-                <a:satMod val="300000"/>
+                <a:lumMod val="105000"/>
+                <a:satMod val="103000"/>
+                <a:tint val="73000"/>
               </a:schemeClr>
             </a:gs>
             <a:gs pos="100000">
               <a:schemeClr val="phClr">
-                <a:tint val="15000"/>
-                <a:satMod val="350000"/>
+                <a:lumMod val="105000"/>
+                <a:satMod val="109000"/>
+                <a:tint val="81000"/>
               </a:schemeClr>
             </a:gs>
           </a:gsLst>
-          <a:lin ang="16200000" scaled="1"/>
+          <a:lin ang="5400000" scaled="0"/>
         </a:gradFill>
         <a:gradFill rotWithShape="1">
           <a:gsLst>
             <a:gs pos="0">
               <a:schemeClr val="phClr">
-                <a:tint val="100000"/>
+                <a:satMod val="103000"/>
+                <a:lumMod val="102000"/>
+                <a:tint val="94000"/>
+              </a:schemeClr>
+            </a:gs>
+            <a:gs pos="50000">
+              <a:schemeClr val="phClr">
+                <a:satMod val="110000"/>
+                <a:lumMod val="100000"/>
                 <a:shade val="100000"/>
-                <a:satMod val="130000"/>
               </a:schemeClr>
             </a:gs>
             <a:gs pos="100000">
               <a:schemeClr val="phClr">
-                <a:tint val="50000"/>
-                <a:shade val="100000"/>
-                <a:satMod val="350000"/>
+                <a:lumMod val="99000"/>
+                <a:satMod val="120000"/>
+                <a:shade val="78000"/>
               </a:schemeClr>
             </a:gs>
           </a:gsLst>
-          <a:lin ang="16200000" scaled="0"/>
+          <a:lin ang="5400000" scaled="0"/>
         </a:gradFill>
       </a:fillStyleLst>
       <a:lnStyleLst>
-        <a:ln w="9525" cap="flat" cmpd="sng" algn="ctr">
+        <a:ln w="12700" cap="flat" cmpd="sng" algn="ctr">
           <a:solidFill>
-            <a:schemeClr val="phClr">
-              <a:shade val="95000"/>
-              <a:satMod val="105000"/>
-            </a:schemeClr>
+            <a:schemeClr val="phClr"/>
           </a:solidFill>
           <a:prstDash val="solid"/>
+          <a:miter lim="800000"/>
+        </a:ln>
+        <a:ln w="19050" cap="flat" cmpd="sng" algn="ctr">
+          <a:solidFill>
+            <a:schemeClr val="phClr"/>
+          </a:solidFill>
+          <a:prstDash val="solid"/>
+          <a:miter lim="800000"/>
         </a:ln>
         <a:ln w="25400" cap="flat" cmpd="sng" algn="ctr">
           <a:solidFill>
             <a:schemeClr val="phClr"/>
           </a:solidFill>
           <a:prstDash val="solid"/>
-        </a:ln>
-        <a:ln w="38100" cap="flat" cmpd="sng" algn="ctr">
-          <a:solidFill>
-            <a:schemeClr val="phClr"/>
-          </a:solidFill>
-          <a:prstDash val="solid"/>
+          <a:miter lim="800000"/>
         </a:ln>
       </a:lnStyleLst>
       <a:effectStyleLst>
         <a:effectStyle>
+          <a:effectLst/>
+        </a:effectStyle>
+        <a:effectStyle>
+          <a:effectLst/>
+        </a:effectStyle>
+        <a:effectStyle>
           <a:effectLst>
-            <a:outerShdw blurRad="40000" dist="20000" dir="5400000" rotWithShape="0">
+            <a:outerShdw blurRad="57150" dist="19050" dir="5400000" algn="ctr" rotWithShape="0">
               <a:srgbClr val="000000">
-                <a:alpha val="38000"/>
+                <a:alpha val="63000"/>
               </a:srgbClr>
             </a:outerShdw>
           </a:effectLst>
-        </a:effectStyle>
-        <a:effectStyle>
-          <a:effectLst>
-            <a:outerShdw blurRad="40000" dist="23000" dir="5400000" rotWithShape="0">
-              <a:srgbClr val="000000">
-                <a:alpha val="35000"/>
-              </a:srgbClr>
-            </a:outerShdw>
-          </a:effectLst>
-        </a:effectStyle>
-        <a:effectStyle>
-          <a:effectLst>
-            <a:outerShdw blurRad="40000" dist="23000" dir="5400000" rotWithShape="0">
-              <a:srgbClr val="000000">
-                <a:alpha val="35000"/>
-              </a:srgbClr>
-            </a:outerShdw>
-          </a:effectLst>
-          <a:scene3d>
-            <a:camera prst="orthographicFront">
-              <a:rot lat="0" lon="0" rev="0"/>
-            </a:camera>
-            <a:lightRig rig="threePt" dir="t">
-              <a:rot lat="0" lon="0" rev="1200000"/>
-            </a:lightRig>
-          </a:scene3d>
-          <a:sp3d>
-            <a:bevelT w="63500" h="25400"/>
-          </a:sp3d>
         </a:effectStyle>
       </a:effectStyleLst>
       <a:bgFillStyleLst>
         <a:solidFill>
           <a:schemeClr val="phClr"/>
         </a:solidFill>
+        <a:solidFill>
+          <a:schemeClr val="phClr">
+            <a:tint val="95000"/>
+            <a:satMod val="170000"/>
+          </a:schemeClr>
+        </a:solidFill>
         <a:gradFill rotWithShape="1">
           <a:gsLst>
             <a:gs pos="0">
               <a:schemeClr val="phClr">
-                <a:tint val="40000"/>
-                <a:satMod val="350000"/>
+                <a:tint val="93000"/>
+                <a:satMod val="150000"/>
+                <a:shade val="98000"/>
+                <a:lumMod val="102000"/>
               </a:schemeClr>
             </a:gs>
-            <a:gs pos="40000">
+            <a:gs pos="50000">
               <a:schemeClr val="phClr">
-                <a:tint val="45000"/>
-                <a:shade val="99000"/>
-                <a:satMod val="350000"/>
+                <a:tint val="98000"/>
+                <a:satMod val="130000"/>
+                <a:shade val="90000"/>
+                <a:lumMod val="103000"/>
               </a:schemeClr>
             </a:gs>
             <a:gs pos="100000">
               <a:schemeClr val="phClr">
-                <a:shade val="20000"/>
-                <a:satMod val="255000"/>
+                <a:shade val="63000"/>
+                <a:satMod val="120000"/>
               </a:schemeClr>
             </a:gs>
           </a:gsLst>
-          <a:path path="circle">
-            <a:fillToRect l="50000" t="-80000" r="50000" b="180000"/>
-          </a:path>
-        </a:gradFill>
-        <a:gradFill rotWithShape="1">
-          <a:gsLst>
-            <a:gs pos="0">
-              <a:schemeClr val="phClr">
-                <a:tint val="80000"/>
-                <a:satMod val="300000"/>
-              </a:schemeClr>
-            </a:gs>
-            <a:gs pos="100000">
-              <a:schemeClr val="phClr">
-                <a:shade val="30000"/>
-                <a:satMod val="200000"/>
-              </a:schemeClr>
-            </a:gs>
-          </a:gsLst>
-          <a:path path="circle">
-            <a:fillToRect l="50000" t="50000" r="50000" b="50000"/>
-          </a:path>
+          <a:lin ang="5400000" scaled="0"/>
         </a:gradFill>
       </a:bgFillStyleLst>
     </a:fmtScheme>
   </a:themeElements>
   <a:objectDefaults>
-    <a:spDef>
-      <a:spPr/>
-      <a:bodyPr/>
-      <a:lstStyle/>
-      <a:style>
-        <a:lnRef idx="1">
-          <a:schemeClr val="accent1"/>
-        </a:lnRef>
-        <a:fillRef idx="3">
-          <a:schemeClr val="accent1"/>
-        </a:fillRef>
-        <a:effectRef idx="2">
-          <a:schemeClr val="accent1"/>
-        </a:effectRef>
-        <a:fontRef idx="minor">
-          <a:schemeClr val="lt1"/>
-        </a:fontRef>
-      </a:style>
-    </a:spDef>
     <a:lnDef>
       <a:spPr/>
       <a:bodyPr/>
@@ -14546,5 +14487,10 @@
     </a:lnDef>
   </a:objectDefaults>
   <a:extraClrSchemeLst/>
+  <a:extLst>
+    <a:ext uri="{05A4C25C-085E-4340-85A3-A5531E510DB2}">
+      <thm15:themeFamily xmlns:thm15="http://schemas.microsoft.com/office/thememl/2012/main" name="Office Theme" id="{2E142A2C-CD16-42D6-873A-C26D2A0506FA}" vid="{1BDDFF52-6CD6-40A5-AB3C-68EB2F1E4D0A}"/>
+    </a:ext>
+  </a:extLst>
 </a:theme>
 </file>
</xml_diff>